<commit_message>
Formato Assurance ITO v1.1: regla de reiteración y prioridad por tipo de evento
- Foco solo con 2 o más eventos N1/N2 del mismo tema en 14 días.
- Prioridad: ACC con lesión > ACC daño material > CAAP (N1) > CBP > HAP (N2).
- Foco como instrucción específica para el turno entrante.
- Fila 5 SI PRO fija hasta recibir la directriz GSSO.

Co-Authored-By: Claude Opus 5.5 <noreply@anthropic.com>
Claude-Session: https://claude.ai/code/session_017MaLNPnWzNhW9Tdfmjv67V
</commit_message>
<xml_diff>
--- a/FORMATO_ASSURANCE_ITO_v1.1.pptx
+++ b/FORMATO_ASSURANCE_ITO_v1.1.pptx
@@ -6781,7 +6781,7 @@
                 <a:ea typeface="Arial" pitchFamily="34" charset="-122"/>
                 <a:cs typeface="Arial" pitchFamily="34" charset="-120"/>
               </a:rPr>
-              <a:t>3. SELECCIÓN DE FOCOS (filas 1 a 4)</a:t>
+              <a:t>3. SELECCIÓN DE FOCOS (filas 1 a 4) – REGLA DE REITERACIÓN</a:t>
             </a:r>
             <a:endParaRPr lang="en-US" sz="600" dirty="0"/>
           </a:p>
@@ -6798,7 +6798,7 @@
                 <a:ea typeface="Arial" pitchFamily="34" charset="-122"/>
                 <a:cs typeface="Arial" pitchFamily="34" charset="-120"/>
               </a:rPr>
-              <a:t>- Solo eventos N1 y N2 del período (ACC, CAAP, HAP, CBP). Nunca uses HBP como foco.</a:t>
+              <a:t>- Un foco solo se crea cuando hay REITERACIÓN: 2 o más eventos N1/N2 (ACC, CAAP, HAP, CBP) del período relacionados con un mismo tema (p. ej.: izaje, trabajo en altura/andamios, vehículos y equipos, energía eléctrica, excavaciones/zanjas). Un evento aislado, aunque sea N1, NO genera foco: menciónalo al usuario en el control de calidad.</a:t>
             </a:r>
             <a:endParaRPr lang="en-US" sz="600" dirty="0"/>
           </a:p>
@@ -6815,7 +6815,7 @@
                 <a:ea typeface="Arial" pitchFamily="34" charset="-122"/>
                 <a:cs typeface="Arial" pitchFamily="34" charset="-120"/>
               </a:rPr>
-              <a:t>- Agrupa los eventos por riesgo (p. ej.: izaje, trabajo en altura/andamios, vehículos y equipos, energía eléctrica, excavaciones/zanjas). Un foco = un riesgo.</a:t>
+              <a:t>- Para agrupar por tema usa "RIESGO INVOLUCRADO" y también "Titulo" y "Descripción": muchos eventos dicen "Otro riesgo de seguridad" pero pertenecen a un tema (p. ej., un CBP por retiro de eslinga pertenece a izaje).</a:t>
             </a:r>
             <a:endParaRPr lang="en-US" sz="600" dirty="0"/>
           </a:p>
@@ -6832,7 +6832,7 @@
                 <a:ea typeface="Arial" pitchFamily="34" charset="-122"/>
                 <a:cs typeface="Arial" pitchFamily="34" charset="-120"/>
               </a:rPr>
-              <a:t>- Ordena primero todos los focos N1 y luego los N2. Dentro de cada nivel: más eventos del mismo riesgo y, luego, más recientes.</a:t>
+              <a:t>- Nunca uses HBP (N3) como foco ni para contar reiteración.</a:t>
             </a:r>
             <a:endParaRPr lang="en-US" sz="600" dirty="0"/>
           </a:p>
@@ -6849,7 +6849,7 @@
                 <a:ea typeface="Arial" pitchFamily="34" charset="-122"/>
                 <a:cs typeface="Arial" pitchFamily="34" charset="-120"/>
               </a:rPr>
-              <a:t>- Máximo 4 focos de eventos. Si hay más riesgos N1/N2, deja fuera los de menor prioridad e infórmalo al usuario. Si hay menos, elimina las filas sobrantes (nunca la fila 5).</a:t>
+              <a:t>- Máximo 4 focos. Si hay más temas reiterados, deja fuera los de menor prioridad e infórmalo. Si hay menos, elimina las filas sobrantes (nunca la fila 5). Si no hay ninguna reiteración, deja solo la fila 5 e infórmalo.</a:t>
             </a:r>
             <a:endParaRPr lang="en-US" sz="600" dirty="0"/>
           </a:p>
@@ -6883,7 +6883,7 @@
                 <a:ea typeface="Arial" pitchFamily="34" charset="-122"/>
                 <a:cs typeface="Arial" pitchFamily="34" charset="-120"/>
               </a:rPr>
-              <a:t>4. NIVEL / PRIORIDAD (primera columna)</a:t>
+              <a:t>4. NIVEL Y PRIORIDAD POR TIPO DE EVENTO</a:t>
             </a:r>
             <a:endParaRPr lang="en-US" sz="600" dirty="0"/>
           </a:p>
@@ -6900,7 +6900,7 @@
                 <a:ea typeface="Arial" pitchFamily="34" charset="-122"/>
                 <a:cs typeface="Arial" pitchFamily="34" charset="-120"/>
               </a:rPr>
-              <a:t>- Texto: número del foco + "N1 · CRITICIDAD ALTA" o "N2 · CRITICIDAD INTERMEDIA", según el evento de mayor nivel del foco.</a:t>
+              <a:t>Tabla de prioridad (1 = mayor):</a:t>
             </a:r>
             <a:endParaRPr lang="en-US" sz="600" dirty="0"/>
           </a:p>
@@ -6917,7 +6917,7 @@
                 <a:ea typeface="Arial" pitchFamily="34" charset="-122"/>
                 <a:cs typeface="Arial" pitchFamily="34" charset="-120"/>
               </a:rPr>
-              <a:t>- Color de la celda: N1 = rojo C62828; N2 = naranja E67E22. La plantilla trae 3 filas N1 y 1 fila N2 como referencia: ajusta texto y color de cada fila al nivel real del foco.</a:t>
+              <a:t>  1. ACC con lesión a personas ........ N1 · CRITICIDAD ALTA</a:t>
             </a:r>
             <a:endParaRPr lang="en-US" sz="600" dirty="0"/>
           </a:p>
@@ -6934,6 +6934,142 @@
                 <a:ea typeface="Arial" pitchFamily="34" charset="-122"/>
                 <a:cs typeface="Arial" pitchFamily="34" charset="-120"/>
               </a:rPr>
+              <a:t>  2. ACC con daño material (DM) ....... N1 · CRITICIDAD ALTA</a:t>
+            </a:r>
+            <a:endParaRPr lang="en-US" sz="600" dirty="0"/>
+          </a:p>
+          <a:p>
+            <a:pPr marL="0" indent="0">
+              <a:buNone/>
+            </a:pPr>
+            <a:r>
+              <a:rPr lang="en-US" sz="600" dirty="0">
+                <a:solidFill>
+                  <a:srgbClr val="222222"/>
+                </a:solidFill>
+                <a:latin typeface="Arial" pitchFamily="34" charset="0"/>
+                <a:ea typeface="Arial" pitchFamily="34" charset="-122"/>
+                <a:cs typeface="Arial" pitchFamily="34" charset="-120"/>
+              </a:rPr>
+              <a:t>  3. CAAP ............................. N1 · CRITICIDAD ALTA</a:t>
+            </a:r>
+            <a:endParaRPr lang="en-US" sz="600" dirty="0"/>
+          </a:p>
+          <a:p>
+            <a:pPr marL="0" indent="0">
+              <a:buNone/>
+            </a:pPr>
+            <a:r>
+              <a:rPr lang="en-US" sz="600" dirty="0">
+                <a:solidFill>
+                  <a:srgbClr val="222222"/>
+                </a:solidFill>
+                <a:latin typeface="Arial" pitchFamily="34" charset="0"/>
+                <a:ea typeface="Arial" pitchFamily="34" charset="-122"/>
+                <a:cs typeface="Arial" pitchFamily="34" charset="-120"/>
+              </a:rPr>
+              <a:t>  4. CBP (interacción próxima persona–situación) ... N2 · CRITICIDAD INTERMEDIA</a:t>
+            </a:r>
+            <a:endParaRPr lang="en-US" sz="600" dirty="0"/>
+          </a:p>
+          <a:p>
+            <a:pPr marL="0" indent="0">
+              <a:buNone/>
+            </a:pPr>
+            <a:r>
+              <a:rPr lang="en-US" sz="600" dirty="0">
+                <a:solidFill>
+                  <a:srgbClr val="222222"/>
+                </a:solidFill>
+                <a:latin typeface="Arial" pitchFamily="34" charset="0"/>
+                <a:ea typeface="Arial" pitchFamily="34" charset="-122"/>
+                <a:cs typeface="Arial" pitchFamily="34" charset="-120"/>
+              </a:rPr>
+              <a:t>  5. HAP (control crítico no implementado o erosionado) ... N2 · CRITICIDAD INTERMEDIA</a:t>
+            </a:r>
+            <a:endParaRPr lang="en-US" sz="600" dirty="0"/>
+          </a:p>
+          <a:p>
+            <a:pPr marL="0" indent="0">
+              <a:buNone/>
+            </a:pPr>
+            <a:r>
+              <a:rPr lang="en-US" sz="600" dirty="0">
+                <a:solidFill>
+                  <a:srgbClr val="222222"/>
+                </a:solidFill>
+                <a:latin typeface="Arial" pitchFamily="34" charset="0"/>
+                <a:ea typeface="Arial" pitchFamily="34" charset="-122"/>
+                <a:cs typeface="Arial" pitchFamily="34" charset="-120"/>
+              </a:rPr>
+              <a:t>  —  HBP ............................. N3 · no ingresa como foco (solo Recurrente)</a:t>
+            </a:r>
+            <a:endParaRPr lang="en-US" sz="600" dirty="0"/>
+          </a:p>
+          <a:p>
+            <a:pPr marL="0" indent="0">
+              <a:buNone/>
+            </a:pPr>
+            <a:r>
+              <a:rPr lang="en-US" sz="600" dirty="0">
+                <a:solidFill>
+                  <a:srgbClr val="222222"/>
+                </a:solidFill>
+                <a:latin typeface="Arial" pitchFamily="34" charset="0"/>
+                <a:ea typeface="Arial" pitchFamily="34" charset="-122"/>
+                <a:cs typeface="Arial" pitchFamily="34" charset="-120"/>
+              </a:rPr>
+              <a:t>- Nivel del foco = nivel del evento de mayor prioridad entre sus eventos de origen (basta un ACC o CAAP para que el foco sea N1).</a:t>
+            </a:r>
+            <a:endParaRPr lang="en-US" sz="600" dirty="0"/>
+          </a:p>
+          <a:p>
+            <a:pPr marL="0" indent="0">
+              <a:buNone/>
+            </a:pPr>
+            <a:r>
+              <a:rPr lang="en-US" sz="600" dirty="0">
+                <a:solidFill>
+                  <a:srgbClr val="222222"/>
+                </a:solidFill>
+                <a:latin typeface="Arial" pitchFamily="34" charset="0"/>
+                <a:ea typeface="Arial" pitchFamily="34" charset="-122"/>
+                <a:cs typeface="Arial" pitchFamily="34" charset="-120"/>
+              </a:rPr>
+              <a:t>- Orden de los focos: primero todos los N1 y luego los N2. Dentro del mismo nivel: (a) el evento de mayor prioridad según la tabla, (b) mayor cantidad de eventos reiterados, (c) evento más reciente.</a:t>
+            </a:r>
+            <a:endParaRPr lang="en-US" sz="600" dirty="0"/>
+          </a:p>
+          <a:p>
+            <a:pPr marL="0" indent="0">
+              <a:buNone/>
+            </a:pPr>
+            <a:r>
+              <a:rPr lang="en-US" sz="600" dirty="0">
+                <a:solidFill>
+                  <a:srgbClr val="222222"/>
+                </a:solidFill>
+                <a:latin typeface="Arial" pitchFamily="34" charset="0"/>
+                <a:ea typeface="Arial" pitchFamily="34" charset="-122"/>
+                <a:cs typeface="Arial" pitchFamily="34" charset="-120"/>
+              </a:rPr>
+              <a:t>- Texto de la celda: número del foco + "N1 · CRITICIDAD ALTA" o "N2 · CRITICIDAD INTERMEDIA". Color: N1 = rojo C62828; N2 = naranja E67E22. Ajusta texto y color de cada fila al nivel real (la plantilla trae 3 filas N1 y 1 N2 solo como referencia).</a:t>
+            </a:r>
+            <a:endParaRPr lang="en-US" sz="600" dirty="0"/>
+          </a:p>
+          <a:p>
+            <a:pPr marL="0" indent="0">
+              <a:buNone/>
+            </a:pPr>
+            <a:r>
+              <a:rPr lang="en-US" sz="600" dirty="0">
+                <a:solidFill>
+                  <a:srgbClr val="222222"/>
+                </a:solidFill>
+                <a:latin typeface="Arial" pitchFamily="34" charset="0"/>
+                <a:ea typeface="Arial" pitchFamily="34" charset="-122"/>
+                <a:cs typeface="Arial" pitchFamily="34" charset="-120"/>
+              </a:rPr>
               <a:t> </a:t>
             </a:r>
             <a:endParaRPr lang="en-US" sz="600" dirty="0"/>
@@ -6968,7 +7104,7 @@
                 <a:ea typeface="Arial" pitchFamily="34" charset="-122"/>
                 <a:cs typeface="Arial" pitchFamily="34" charset="-120"/>
               </a:rPr>
-              <a:t>- No la uses para eventos del Excel ni la elimines. Mantén "DIRECTRIZ GSSO", "GCC" y "QR O PLATAFORMA PASSO (GERENCIA SSO)".</a:t>
+              <a:t>- Por ahora es fija: déjala exactamente como está en la plantilla, sin completar ni modificar ninguna de sus casillas (incluido su texto guía), y no la elimines. Es la única excepción a la regla de reemplazar los corchetes.</a:t>
             </a:r>
             <a:endParaRPr lang="en-US" sz="600" dirty="0"/>
           </a:p>
@@ -6985,7 +7121,7 @@
                 <a:ea typeface="Arial" pitchFamily="34" charset="-122"/>
                 <a:cs typeface="Arial" pitchFamily="34" charset="-120"/>
               </a:rPr>
-              <a:t>- Completa el tema y la instrucción solo si el usuario entrega la directriz GSSO vigente; si no, deja esa casilla como [DATO FALTANTE] y avísale.</a:t>
+              <a:t> </a:t>
             </a:r>
             <a:endParaRPr lang="en-US" sz="600" dirty="0"/>
           </a:p>
@@ -7002,6 +7138,125 @@
                 <a:ea typeface="Arial" pitchFamily="34" charset="-122"/>
                 <a:cs typeface="Arial" pitchFamily="34" charset="-120"/>
               </a:rPr>
+              <a:t>6. FOCO DE ASSURANCE – INSTRUCCIÓN ESPECÍFICA PARA EL TURNO ENTRANTE</a:t>
+            </a:r>
+            <a:endParaRPr lang="en-US" sz="600" dirty="0"/>
+          </a:p>
+          <a:p>
+            <a:pPr marL="0" indent="0">
+              <a:buNone/>
+            </a:pPr>
+            <a:r>
+              <a:rPr lang="en-US" sz="600" dirty="0">
+                <a:solidFill>
+                  <a:srgbClr val="222222"/>
+                </a:solidFill>
+                <a:latin typeface="Arial" pitchFamily="34" charset="0"/>
+                <a:ea typeface="Arial" pitchFamily="34" charset="-122"/>
+                <a:cs typeface="Arial" pitchFamily="34" charset="-120"/>
+              </a:rPr>
+              <a:t>- El foco es una instrucción operacional para el turno que entra. Mientras más específica, mejor; una instrucción general no sirve.</a:t>
+            </a:r>
+            <a:endParaRPr lang="en-US" sz="600" dirty="0"/>
+          </a:p>
+          <a:p>
+            <a:pPr marL="0" indent="0">
+              <a:buNone/>
+            </a:pPr>
+            <a:r>
+              <a:rPr lang="en-US" sz="600" dirty="0">
+                <a:solidFill>
+                  <a:srgbClr val="222222"/>
+                </a:solidFill>
+                <a:latin typeface="Arial" pitchFamily="34" charset="0"/>
+                <a:ea typeface="Arial" pitchFamily="34" charset="-122"/>
+                <a:cs typeface="Arial" pitchFamily="34" charset="-120"/>
+              </a:rPr>
+              <a:t>- Debe indicar: DÓNDE (área/frente, según "AREA_GEO"), QUÉ actividad o equipo (p. ej.: izaje con camión pluma de estructuras modulares), QUÉ control verificar exactamente, QUIÉN lo verifica (supervisor, rigger, operador) y CUÁNDO (antes de cada maniobra, al inicio del turno, etc.).</a:t>
+            </a:r>
+            <a:endParaRPr lang="en-US" sz="600" dirty="0"/>
+          </a:p>
+          <a:p>
+            <a:pPr marL="0" indent="0">
+              <a:buNone/>
+            </a:pPr>
+            <a:r>
+              <a:rPr lang="en-US" sz="600" dirty="0">
+                <a:solidFill>
+                  <a:srgbClr val="222222"/>
+                </a:solidFill>
+                <a:latin typeface="Arial" pitchFamily="34" charset="0"/>
+                <a:ea typeface="Arial" pitchFamily="34" charset="-122"/>
+                <a:cs typeface="Arial" pitchFamily="34" charset="-120"/>
+              </a:rPr>
+              <a:t>- Formato: "Tema del foco." en negrita + instrucción que empieza con un verbo ("Verificar…"). Máximo unos 350 caracteres. Luego, en línea aparte, "Criterio de restricción:" (en negrita) + la condición concreta en que se prohíbe o se detiene la tarea. Máximo unos 150 caracteres.</a:t>
+            </a:r>
+            <a:endParaRPr lang="en-US" sz="600" dirty="0"/>
+          </a:p>
+          <a:p>
+            <a:pPr marL="0" indent="0">
+              <a:buNone/>
+            </a:pPr>
+            <a:r>
+              <a:rPr lang="en-US" sz="600" dirty="0">
+                <a:solidFill>
+                  <a:srgbClr val="222222"/>
+                </a:solidFill>
+                <a:latin typeface="Arial" pitchFamily="34" charset="0"/>
+                <a:ea typeface="Arial" pitchFamily="34" charset="-122"/>
+                <a:cs typeface="Arial" pitchFamily="34" charset="-120"/>
+              </a:rPr>
+              <a:t>- Ejemplo NO válido (general): "Verificar que los izajes se realicen de forma segura."</a:t>
+            </a:r>
+            <a:endParaRPr lang="en-US" sz="600" dirty="0"/>
+          </a:p>
+          <a:p>
+            <a:pPr marL="0" indent="0">
+              <a:buNone/>
+            </a:pPr>
+            <a:r>
+              <a:rPr lang="en-US" sz="600" dirty="0">
+                <a:solidFill>
+                  <a:srgbClr val="222222"/>
+                </a:solidFill>
+                <a:latin typeface="Arial" pitchFamily="34" charset="0"/>
+                <a:ea typeface="Arial" pitchFamily="34" charset="-122"/>
+                <a:cs typeface="Arial" pitchFamily="34" charset="-120"/>
+              </a:rPr>
+              <a:t>- Ejemplo válido (específico): "Izaje – plan por maniobra. Verificar en Piscinas ILS-PLS y Pila Oeste, antes de cada levante con camión pluma o grúa horquilla, que el supervisor valide que el plan de izaje corresponde a la carga real (escala modular, equipo de electrofusión, maxisacos), con área segregada y radio operador–rigger. Criterio de restricción: sin plan específico para la carga o sin segregación, no se iza."</a:t>
+            </a:r>
+            <a:endParaRPr lang="en-US" sz="600" dirty="0"/>
+          </a:p>
+          <a:p>
+            <a:pPr marL="0" indent="0">
+              <a:buNone/>
+            </a:pPr>
+            <a:r>
+              <a:rPr lang="en-US" sz="600" dirty="0">
+                <a:solidFill>
+                  <a:srgbClr val="222222"/>
+                </a:solidFill>
+                <a:latin typeface="Arial" pitchFamily="34" charset="0"/>
+                <a:ea typeface="Arial" pitchFamily="34" charset="-122"/>
+                <a:cs typeface="Arial" pitchFamily="34" charset="-120"/>
+              </a:rPr>
+              <a:t>- Redacta solo a partir de las brechas reales de los eventos de origen. No cites números de estándares o procedimientos que no estén en el Excel.</a:t>
+            </a:r>
+            <a:endParaRPr lang="en-US" sz="600" dirty="0"/>
+          </a:p>
+          <a:p>
+            <a:pPr marL="0" indent="0">
+              <a:buNone/>
+            </a:pPr>
+            <a:r>
+              <a:rPr lang="en-US" sz="600" dirty="0">
+                <a:solidFill>
+                  <a:srgbClr val="222222"/>
+                </a:solidFill>
+                <a:latin typeface="Arial" pitchFamily="34" charset="0"/>
+                <a:ea typeface="Arial" pitchFamily="34" charset="-122"/>
+                <a:cs typeface="Arial" pitchFamily="34" charset="-120"/>
+              </a:rPr>
               <a:t> </a:t>
             </a:r>
             <a:endParaRPr lang="en-US" sz="600" dirty="0"/>
@@ -7019,7 +7274,7 @@
                 <a:ea typeface="Arial" pitchFamily="34" charset="-122"/>
                 <a:cs typeface="Arial" pitchFamily="34" charset="-120"/>
               </a:rPr>
-              <a:t>6. FOCO DE ASSURANCE</a:t>
+              <a:t>7. EVENTO / EVIDENCIA ORIGEN</a:t>
             </a:r>
             <a:endParaRPr lang="en-US" sz="600" dirty="0"/>
           </a:p>
@@ -7036,7 +7291,7 @@
                 <a:ea typeface="Arial" pitchFamily="34" charset="-122"/>
                 <a:cs typeface="Arial" pitchFamily="34" charset="-120"/>
               </a:rPr>
-              <a:t>- Formato: "Tema del foco." en negrita + instrucción que empieza con un verbo ("Verificar…"): qué se revisa, dónde y bajo qué estándar. Máximo unos 350 caracteres.</a:t>
+              <a:t>- Lista TODOS los eventos N1/N2 del período que originan el foco (mínimo 2, por la regla de reiteración), ordenados según la tabla de prioridad del punto 4. Si son más de 4, lista los 4 de mayor prioridad y agrega "+ N eventos más".</a:t>
             </a:r>
             <a:endParaRPr lang="en-US" sz="600" dirty="0"/>
           </a:p>
@@ -7053,7 +7308,7 @@
                 <a:ea typeface="Arial" pitchFamily="34" charset="-122"/>
                 <a:cs typeface="Arial" pitchFamily="34" charset="-120"/>
               </a:rPr>
-              <a:t>- Luego, en línea aparte, "Criterio de restricción:" (en negrita) + la condición en que se prohíbe o se detiene la tarea. Máximo unos 150 caracteres.</a:t>
+              <a:t>- Formato fijo por evento: "[T1-3] TIPO ID – EECC:" (en negrita) + qué ocurrió, en una frase de hasta 120 caracteres. TIPO = ACC, CAAP, HAP o CBP.</a:t>
             </a:r>
             <a:endParaRPr lang="en-US" sz="600" dirty="0"/>
           </a:p>
@@ -7070,7 +7325,7 @@
                 <a:ea typeface="Arial" pitchFamily="34" charset="-122"/>
                 <a:cs typeface="Arial" pitchFamily="34" charset="-120"/>
               </a:rPr>
-              <a:t>- Redacta a partir de las brechas reales de los eventos. No cites números de estándares o procedimientos que no estén en el Excel.</a:t>
+              <a:t> </a:t>
             </a:r>
             <a:endParaRPr lang="en-US" sz="600" dirty="0"/>
           </a:p>
@@ -7087,6 +7342,57 @@
                 <a:ea typeface="Arial" pitchFamily="34" charset="-122"/>
                 <a:cs typeface="Arial" pitchFamily="34" charset="-120"/>
               </a:rPr>
+              <a:t>8. HERRAMIENTA PREVENTIVA SGE (explicar qué se tiene que realizar durante el turno)</a:t>
+            </a:r>
+            <a:endParaRPr lang="en-US" sz="600" dirty="0"/>
+          </a:p>
+          <a:p>
+            <a:pPr marL="0" indent="0">
+              <a:buNone/>
+            </a:pPr>
+            <a:r>
+              <a:rPr lang="en-US" sz="600" dirty="0">
+                <a:solidFill>
+                  <a:srgbClr val="222222"/>
+                </a:solidFill>
+                <a:latin typeface="Arial" pitchFamily="34" charset="0"/>
+                <a:ea typeface="Arial" pitchFamily="34" charset="-122"/>
+                <a:cs typeface="Arial" pitchFamily="34" charset="-120"/>
+              </a:rPr>
+              <a:t>- Herramienta(s) del SGE unidas con "+", y para cada una la acción concreta a realizar durante el turno: qué, dónde y con qué frecuencia. Ej.: "CdP Maniobras de Izaje: 1 por frente con izaje al inicio del turno + ASP antes de cada maniobra".</a:t>
+            </a:r>
+            <a:endParaRPr lang="en-US" sz="600" dirty="0"/>
+          </a:p>
+          <a:p>
+            <a:pPr marL="0" indent="0">
+              <a:buNone/>
+            </a:pPr>
+            <a:r>
+              <a:rPr lang="en-US" sz="600" dirty="0">
+                <a:solidFill>
+                  <a:srgbClr val="222222"/>
+                </a:solidFill>
+                <a:latin typeface="Arial" pitchFamily="34" charset="0"/>
+                <a:ea typeface="Arial" pitchFamily="34" charset="-122"/>
+                <a:cs typeface="Arial" pitchFamily="34" charset="-120"/>
+              </a:rPr>
+              <a:t>- Herramientas de referencia: GCC, CdP [tema], ASP, PTS, Gestión del Cambio, Desafío en Terreno, Inspección de Plataformas de Andamios, EdC Vehículo Liviano, Inspección de Equipos, Acompañamiento ASP. Usa también las que figuren en el Excel (prefijos como "CdP-", "ASP-", "EdC-" en el título).</a:t>
+            </a:r>
+            <a:endParaRPr lang="en-US" sz="600" dirty="0"/>
+          </a:p>
+          <a:p>
+            <a:pPr marL="0" indent="0">
+              <a:buNone/>
+            </a:pPr>
+            <a:r>
+              <a:rPr lang="en-US" sz="600" dirty="0">
+                <a:solidFill>
+                  <a:srgbClr val="222222"/>
+                </a:solidFill>
+                <a:latin typeface="Arial" pitchFamily="34" charset="0"/>
+                <a:ea typeface="Arial" pitchFamily="34" charset="-122"/>
+                <a:cs typeface="Arial" pitchFamily="34" charset="-120"/>
+              </a:rPr>
               <a:t> </a:t>
             </a:r>
             <a:endParaRPr lang="en-US" sz="600" dirty="0"/>
@@ -7104,7 +7410,7 @@
                 <a:ea typeface="Arial" pitchFamily="34" charset="-122"/>
                 <a:cs typeface="Arial" pitchFamily="34" charset="-120"/>
               </a:rPr>
-              <a:t>7. EVENTO / EVIDENCIA ORIGEN</a:t>
+              <a:t>9. EVIDENCIA / REGISTRO ESPERADO</a:t>
             </a:r>
             <a:endParaRPr lang="en-US" sz="600" dirty="0"/>
           </a:p>
@@ -7121,7 +7427,7 @@
                 <a:ea typeface="Arial" pitchFamily="34" charset="-122"/>
                 <a:cs typeface="Arial" pitchFamily="34" charset="-120"/>
               </a:rPr>
-              <a:t>- Formato fijo por evento: "[T1-3] TIPO ID – EECC:" (en negrita) + qué ocurrió, en una frase de hasta 120 caracteres. TIPO = ACC, CAAP, HAP o CBP.</a:t>
+              <a:t>- Registros concretos y verificables separados por "/", terminando siempre en "registro fotográfico".</a:t>
             </a:r>
             <a:endParaRPr lang="en-US" sz="600" dirty="0"/>
           </a:p>
@@ -7138,7 +7444,7 @@
                 <a:ea typeface="Arial" pitchFamily="34" charset="-122"/>
                 <a:cs typeface="Arial" pitchFamily="34" charset="-120"/>
               </a:rPr>
-              <a:t>- Máximo 3 eventos por foco, solo N1 y N2; elige los de mayor nivel.</a:t>
+              <a:t> </a:t>
             </a:r>
             <a:endParaRPr lang="en-US" sz="600" dirty="0"/>
           </a:p>
@@ -7155,6 +7461,57 @@
                 <a:ea typeface="Arial" pitchFamily="34" charset="-122"/>
                 <a:cs typeface="Arial" pitchFamily="34" charset="-120"/>
               </a:rPr>
+              <a:t>10. RECURRENTE (única sección donde se usan HBP)</a:t>
+            </a:r>
+            <a:endParaRPr lang="en-US" sz="600" dirty="0"/>
+          </a:p>
+          <a:p>
+            <a:pPr marL="0" indent="0">
+              <a:buNone/>
+            </a:pPr>
+            <a:r>
+              <a:rPr lang="en-US" sz="600" dirty="0">
+                <a:solidFill>
+                  <a:srgbClr val="222222"/>
+                </a:solidFill>
+                <a:latin typeface="Arial" pitchFamily="34" charset="0"/>
+                <a:ea typeface="Arial" pitchFamily="34" charset="-122"/>
+                <a:cs typeface="Arial" pitchFamily="34" charset="-120"/>
+              </a:rPr>
+              <a:t>- "N eventos HBP — tema (n) · tema (n). Refuerzo transversal en todos los recorridos y al cierre de cada tarea."</a:t>
+            </a:r>
+            <a:endParaRPr lang="en-US" sz="600" dirty="0"/>
+          </a:p>
+          <a:p>
+            <a:pPr marL="0" indent="0">
+              <a:buNone/>
+            </a:pPr>
+            <a:r>
+              <a:rPr lang="en-US" sz="600" dirty="0">
+                <a:solidFill>
+                  <a:srgbClr val="222222"/>
+                </a:solidFill>
+                <a:latin typeface="Arial" pitchFamily="34" charset="0"/>
+                <a:ea typeface="Arial" pitchFamily="34" charset="-122"/>
+                <a:cs typeface="Arial" pitchFamily="34" charset="-120"/>
+              </a:rPr>
+              <a:t>- N = total de HBP del período. Menciona los 2 o 3 temas más repetidos. Verifica la suma: los subtotales no pueden superar N.</a:t>
+            </a:r>
+            <a:endParaRPr lang="en-US" sz="600" dirty="0"/>
+          </a:p>
+          <a:p>
+            <a:pPr marL="0" indent="0">
+              <a:buNone/>
+            </a:pPr>
+            <a:r>
+              <a:rPr lang="en-US" sz="600" dirty="0">
+                <a:solidFill>
+                  <a:srgbClr val="222222"/>
+                </a:solidFill>
+                <a:latin typeface="Arial" pitchFamily="34" charset="0"/>
+                <a:ea typeface="Arial" pitchFamily="34" charset="-122"/>
+                <a:cs typeface="Arial" pitchFamily="34" charset="-120"/>
+              </a:rPr>
               <a:t> </a:t>
             </a:r>
             <a:endParaRPr lang="en-US" sz="600" dirty="0"/>
@@ -7172,7 +7529,7 @@
                 <a:ea typeface="Arial" pitchFamily="34" charset="-122"/>
                 <a:cs typeface="Arial" pitchFamily="34" charset="-120"/>
               </a:rPr>
-              <a:t>8. HERRAMIENTA PREVENTIVA SGE (explicar qué se tiene que realizar durante el turno)</a:t>
+              <a:t>11. SÍNTESIS Y RECORRIDOS</a:t>
             </a:r>
             <a:endParaRPr lang="en-US" sz="600" dirty="0"/>
           </a:p>
@@ -7189,7 +7546,7 @@
                 <a:ea typeface="Arial" pitchFamily="34" charset="-122"/>
                 <a:cs typeface="Arial" pitchFamily="34" charset="-120"/>
               </a:rPr>
-              <a:t>- Herramienta(s) del SGE unidas con "+", y para cada una la acción concreta a realizar durante el turno: qué, dónde y con qué frecuencia. Ej.: "CdP Maniobras de Izaje: 1 por frente con izaje al inicio del turno + ASP antes de cada maniobra".</a:t>
+              <a:t>- Bloque AM y Bloque Mediodía: áreas reales tomadas de "AREA_GEO" + 3 controles, cada uno con el N° de foco entre paréntesis, p. ej. "Plan de izaje específico por maniobra (1)". Asigna al AM los focos de inicio de jornada (izaje, pre-uso de vehículos y equipos) y al Mediodía los de intervención (plataformas, instalaciones eléctricas, excavaciones).</a:t>
             </a:r>
             <a:endParaRPr lang="en-US" sz="600" dirty="0"/>
           </a:p>
@@ -7206,7 +7563,7 @@
                 <a:ea typeface="Arial" pitchFamily="34" charset="-122"/>
                 <a:cs typeface="Arial" pitchFamily="34" charset="-120"/>
               </a:rPr>
-              <a:t>- Herramientas de referencia: GCC, CdP [tema], ASP, PTS, Gestión del Cambio, Desafío en Terreno, Inspección de Plataformas de Andamios, EdC Vehículo Liviano, Inspección de Equipos, Acompañamiento ASP. Usa también las que figuren en el Excel (prefijos como "CdP-", "ASP-", "EdC-" en el título).</a:t>
+              <a:t>- Bloque PM: mantén "Gestión SAP · CdP pendientes · Entrega de turno" y sus líneas fijas. En "Actualizar PTS con brechas de CdP:" indica las brechas que el Excel respalde; si no hay, elimina esa línea.</a:t>
             </a:r>
             <a:endParaRPr lang="en-US" sz="600" dirty="0"/>
           </a:p>
@@ -7223,6 +7580,57 @@
                 <a:ea typeface="Arial" pitchFamily="34" charset="-122"/>
                 <a:cs typeface="Arial" pitchFamily="34" charset="-120"/>
               </a:rPr>
+              <a:t>- Recuadro "TENDENCIAS ASOCIADAS A CONTROLES CRÍTICOS": patrones del período (N1, N2 y N3) cuyo "CONTROL CRITICO" corresponde a un control crítico específico (por ejemplo, los marcados "(C.C.)"). Formato: "Tema: control crítico afectado (n)".</a:t>
+            </a:r>
+            <a:endParaRPr lang="en-US" sz="600" dirty="0"/>
+          </a:p>
+          <a:p>
+            <a:pPr marL="0" indent="0">
+              <a:buNone/>
+            </a:pPr>
+            <a:r>
+              <a:rPr lang="en-US" sz="600" dirty="0">
+                <a:solidFill>
+                  <a:srgbClr val="222222"/>
+                </a:solidFill>
+                <a:latin typeface="Arial" pitchFamily="34" charset="0"/>
+                <a:ea typeface="Arial" pitchFamily="34" charset="-122"/>
+                <a:cs typeface="Arial" pitchFamily="34" charset="-120"/>
+              </a:rPr>
+              <a:t>- Recuadro "TENDENCIAS NO ASOCIADAS A CONTROLES CRÍTICOS": patrones cuyo "CONTROL CRITICO" es "Otro", "Sin Información" o está vacío. Formato: "Tema (n)".</a:t>
+            </a:r>
+            <a:endParaRPr lang="en-US" sz="600" dirty="0"/>
+          </a:p>
+          <a:p>
+            <a:pPr marL="0" indent="0">
+              <a:buNone/>
+            </a:pPr>
+            <a:r>
+              <a:rPr lang="en-US" sz="600" dirty="0">
+                <a:solidFill>
+                  <a:srgbClr val="222222"/>
+                </a:solidFill>
+                <a:latin typeface="Arial" pitchFamily="34" charset="0"/>
+                <a:ea typeface="Arial" pitchFamily="34" charset="-122"/>
+                <a:cs typeface="Arial" pitchFamily="34" charset="-120"/>
+              </a:rPr>
+              <a:t>- Máximo 5 viñetas de 1 línea (unos 50 caracteres) por recuadro, de mayor a menor cantidad.</a:t>
+            </a:r>
+            <a:endParaRPr lang="en-US" sz="600" dirty="0"/>
+          </a:p>
+          <a:p>
+            <a:pPr marL="0" indent="0">
+              <a:buNone/>
+            </a:pPr>
+            <a:r>
+              <a:rPr lang="en-US" sz="600" dirty="0">
+                <a:solidFill>
+                  <a:srgbClr val="222222"/>
+                </a:solidFill>
+                <a:latin typeface="Arial" pitchFamily="34" charset="0"/>
+                <a:ea typeface="Arial" pitchFamily="34" charset="-122"/>
+                <a:cs typeface="Arial" pitchFamily="34" charset="-120"/>
+              </a:rPr>
               <a:t> </a:t>
             </a:r>
             <a:endParaRPr lang="en-US" sz="600" dirty="0"/>
@@ -7240,7 +7648,7 @@
                 <a:ea typeface="Arial" pitchFamily="34" charset="-122"/>
                 <a:cs typeface="Arial" pitchFamily="34" charset="-120"/>
               </a:rPr>
-              <a:t>9. EVIDENCIA / REGISTRO ESPERADO</a:t>
+              <a:t>12. ENCABEZADO</a:t>
             </a:r>
             <a:endParaRPr lang="en-US" sz="600" dirty="0"/>
           </a:p>
@@ -7257,7 +7665,7 @@
                 <a:ea typeface="Arial" pitchFamily="34" charset="-122"/>
                 <a:cs typeface="Arial" pitchFamily="34" charset="-120"/>
               </a:rPr>
-              <a:t>- Registros concretos y verificables separados por "/", terminando siempre en "registro fotográfico".</a:t>
+              <a:t>- Título: "ASSURANCE TURNO 1-3" o "ASSURANCE TURNO 2-4". Fecha/Período: "DD al DD MES". Turno: marca ☒ en el que corresponde.</a:t>
             </a:r>
             <a:endParaRPr lang="en-US" sz="600" dirty="0"/>
           </a:p>
@@ -7274,6 +7682,23 @@
                 <a:ea typeface="Arial" pitchFamily="34" charset="-122"/>
                 <a:cs typeface="Arial" pitchFamily="34" charset="-120"/>
               </a:rPr>
+              <a:t>- Inspector ITO, Proyecto/EECC y Área/Sector: complétalos solo si el usuario los entrega; si no, deja la línea en blanco.</a:t>
+            </a:r>
+            <a:endParaRPr lang="en-US" sz="600" dirty="0"/>
+          </a:p>
+          <a:p>
+            <a:pPr marL="0" indent="0">
+              <a:buNone/>
+            </a:pPr>
+            <a:r>
+              <a:rPr lang="en-US" sz="600" dirty="0">
+                <a:solidFill>
+                  <a:srgbClr val="222222"/>
+                </a:solidFill>
+                <a:latin typeface="Arial" pitchFamily="34" charset="0"/>
+                <a:ea typeface="Arial" pitchFamily="34" charset="-122"/>
+                <a:cs typeface="Arial" pitchFamily="34" charset="-120"/>
+              </a:rPr>
               <a:t> </a:t>
             </a:r>
             <a:endParaRPr lang="en-US" sz="600" dirty="0"/>
@@ -7291,7 +7716,7 @@
                 <a:ea typeface="Arial" pitchFamily="34" charset="-122"/>
                 <a:cs typeface="Arial" pitchFamily="34" charset="-120"/>
               </a:rPr>
-              <a:t>10. RECURRENTE (única sección donde se usan HBP)</a:t>
+              <a:t>13. FORMATO (obligatorio)</a:t>
             </a:r>
             <a:endParaRPr lang="en-US" sz="600" dirty="0"/>
           </a:p>
@@ -7308,7 +7733,7 @@
                 <a:ea typeface="Arial" pitchFamily="34" charset="-122"/>
                 <a:cs typeface="Arial" pitchFamily="34" charset="-120"/>
               </a:rPr>
-              <a:t>- "N eventos HBP — tema (n) · tema (n). Refuerzo transversal en todos los recorridos y al cierre de cada tarea."</a:t>
+              <a:t>- No cambies estructura, columnas, colores (salvo el de la celda de nivel según el punto 4), fuentes, íconos ni tamaño de la lámina.</a:t>
             </a:r>
             <a:endParaRPr lang="en-US" sz="600" dirty="0"/>
           </a:p>
@@ -7325,7 +7750,7 @@
                 <a:ea typeface="Arial" pitchFamily="34" charset="-122"/>
                 <a:cs typeface="Arial" pitchFamily="34" charset="-120"/>
               </a:rPr>
-              <a:t>- N = total de HBP del período. Menciona los 2 o 3 temas más repetidos. Verifica la suma: los subtotales no pueden superar N.</a:t>
+              <a:t>- Reemplaza todo texto gris entre [corchetes] por contenido real en color de texto normal (negro, sin cursiva). No debe quedar ningún corchete, salvo [DATO FALTANTE], las marcas de turno [T1-3]/[T2-4] y la fila 5 (fija).</a:t>
             </a:r>
             <a:endParaRPr lang="en-US" sz="600" dirty="0"/>
           </a:p>
@@ -7342,6 +7767,57 @@
                 <a:ea typeface="Arial" pitchFamily="34" charset="-122"/>
                 <a:cs typeface="Arial" pitchFamily="34" charset="-120"/>
               </a:rPr>
+              <a:t>- Letra mínima 6 pt. Si el texto no cabe, resume; no reduzcas más la letra ni agrandes filas.</a:t>
+            </a:r>
+            <a:endParaRPr lang="en-US" sz="600" dirty="0"/>
+          </a:p>
+          <a:p>
+            <a:pPr marL="0" indent="0">
+              <a:buNone/>
+            </a:pPr>
+            <a:r>
+              <a:rPr lang="en-US" sz="600" dirty="0">
+                <a:solidFill>
+                  <a:srgbClr val="222222"/>
+                </a:solidFill>
+                <a:latin typeface="Arial" pitchFamily="34" charset="0"/>
+                <a:ea typeface="Arial" pitchFamily="34" charset="-122"/>
+                <a:cs typeface="Arial" pitchFamily="34" charset="-120"/>
+              </a:rPr>
+              <a:t>- Antes de entregar: elimina la lámina 2 (instructivo). No modifiques ni muevas el cuadro de texto oculto "Instrucciones IA" de la lámina 1.</a:t>
+            </a:r>
+            <a:endParaRPr lang="en-US" sz="600" dirty="0"/>
+          </a:p>
+          <a:p>
+            <a:pPr marL="0" indent="0">
+              <a:buNone/>
+            </a:pPr>
+            <a:r>
+              <a:rPr lang="en-US" sz="600" dirty="0">
+                <a:solidFill>
+                  <a:srgbClr val="222222"/>
+                </a:solidFill>
+                <a:latin typeface="Arial" pitchFamily="34" charset="0"/>
+                <a:ea typeface="Arial" pitchFamily="34" charset="-122"/>
+                <a:cs typeface="Arial" pitchFamily="34" charset="-120"/>
+              </a:rPr>
+              <a:t>- Nombre del archivo: ASSURANCE_TURNO_[1-3 o 2-4]_[DD-DD]_[MES].pptx (ej.: ASSURANCE_TURNO_1-3_07-20_SEP.pptx).</a:t>
+            </a:r>
+            <a:endParaRPr lang="en-US" sz="600" dirty="0"/>
+          </a:p>
+          <a:p>
+            <a:pPr marL="0" indent="0">
+              <a:buNone/>
+            </a:pPr>
+            <a:r>
+              <a:rPr lang="en-US" sz="600" dirty="0">
+                <a:solidFill>
+                  <a:srgbClr val="222222"/>
+                </a:solidFill>
+                <a:latin typeface="Arial" pitchFamily="34" charset="0"/>
+                <a:ea typeface="Arial" pitchFamily="34" charset="-122"/>
+                <a:cs typeface="Arial" pitchFamily="34" charset="-120"/>
+              </a:rPr>
               <a:t> </a:t>
             </a:r>
             <a:endParaRPr lang="en-US" sz="600" dirty="0"/>
@@ -7359,7 +7835,7 @@
                 <a:ea typeface="Arial" pitchFamily="34" charset="-122"/>
                 <a:cs typeface="Arial" pitchFamily="34" charset="-120"/>
               </a:rPr>
-              <a:t>11. SÍNTESIS Y RECORRIDOS</a:t>
+              <a:t>14. ENTREGA</a:t>
             </a:r>
             <a:endParaRPr lang="en-US" sz="600" dirty="0"/>
           </a:p>
@@ -7376,7 +7852,7 @@
                 <a:ea typeface="Arial" pitchFamily="34" charset="-122"/>
                 <a:cs typeface="Arial" pitchFamily="34" charset="-120"/>
               </a:rPr>
-              <a:t>- Bloque AM y Bloque Mediodía: áreas reales tomadas de "AREA_GEO" + 3 controles, cada uno con el N° de foco entre paréntesis, p. ej. "Plan de izaje específico por maniobra (1)". Asigna al AM los focos de inicio de jornada (izaje, pre-uso de vehículos y equipos) y al Mediodía los de intervención (plataformas, instalaciones eléctricas, excavaciones).</a:t>
+              <a:t>- Si puedes editar archivos .pptx: entrega el archivo completado.</a:t>
             </a:r>
             <a:endParaRPr lang="en-US" sz="600" dirty="0"/>
           </a:p>
@@ -7393,7 +7869,7 @@
                 <a:ea typeface="Arial" pitchFamily="34" charset="-122"/>
                 <a:cs typeface="Arial" pitchFamily="34" charset="-120"/>
               </a:rPr>
-              <a:t>- Bloque PM: mantén "Gestión SAP · CdP pendientes · Entrega de turno" y sus líneas fijas. En "Actualizar PTS con brechas de CdP:" indica las brechas que el Excel respalde; si no hay, elimina esa línea.</a:t>
+              <a:t>- Si no puedes: entrega el contenido en texto, ordenado por sección y por fila de la plantilla (Encabezado; Indicadores 14 días; Focos 1 a 4 con sus 5 columnas; Fila 5 SI PRO; Recurrente; Bloques AM/Mediodía/PM; Tendencias no asociadas; Tendencias asociadas a controles críticos), listo para copiar y pegar en cada casilla.</a:t>
             </a:r>
             <a:endParaRPr lang="en-US" sz="600" dirty="0"/>
           </a:p>
@@ -7410,7 +7886,7 @@
                 <a:ea typeface="Arial" pitchFamily="34" charset="-122"/>
                 <a:cs typeface="Arial" pitchFamily="34" charset="-120"/>
               </a:rPr>
-              <a:t>- Recuadro "TENDENCIAS ASOCIADAS A CONTROLES CRÍTICOS": patrones del período (N1, N2 y N3) cuyo "CONTROL CRITICO" corresponde a un control crítico específico (por ejemplo, los marcados "(C.C.)"). Formato: "Tema: control crítico afectado (n)".</a:t>
+              <a:t> </a:t>
             </a:r>
             <a:endParaRPr lang="en-US" sz="600" dirty="0"/>
           </a:p>
@@ -7427,7 +7903,7 @@
                 <a:ea typeface="Arial" pitchFamily="34" charset="-122"/>
                 <a:cs typeface="Arial" pitchFamily="34" charset="-120"/>
               </a:rPr>
-              <a:t>- Recuadro "TENDENCIAS NO ASOCIADAS A CONTROLES CRÍTICOS": patrones cuyo "CONTROL CRITICO" es "Otro", "Sin Información" o está vacío. Formato: "Tema (n)".</a:t>
+              <a:t>15. CONTROL DE CALIDAD (en tu respuesta al usuario, no dentro del archivo)</a:t>
             </a:r>
             <a:endParaRPr lang="en-US" sz="600" dirty="0"/>
           </a:p>
@@ -7444,7 +7920,7 @@
                 <a:ea typeface="Arial" pitchFamily="34" charset="-122"/>
                 <a:cs typeface="Arial" pitchFamily="34" charset="-120"/>
               </a:rPr>
-              <a:t>- Máximo 5 viñetas de 1 línea (unos 50 caracteres) por recuadro, de mayor a menor cantidad.</a:t>
+              <a:t>Al final de tu respuesta incluye un resumen breve con:</a:t>
             </a:r>
             <a:endParaRPr lang="en-US" sz="600" dirty="0"/>
           </a:p>
@@ -7461,7 +7937,7 @@
                 <a:ea typeface="Arial" pitchFamily="34" charset="-122"/>
                 <a:cs typeface="Arial" pitchFamily="34" charset="-120"/>
               </a:rPr>
-              <a:t> </a:t>
+              <a:t>- total de eventos leídos del período y cuántos de cada tipo (ACC, CAAP, HAP, CBP, HBP);</a:t>
             </a:r>
             <a:endParaRPr lang="en-US" sz="600" dirty="0"/>
           </a:p>
@@ -7478,7 +7954,7 @@
                 <a:ea typeface="Arial" pitchFamily="34" charset="-122"/>
                 <a:cs typeface="Arial" pitchFamily="34" charset="-120"/>
               </a:rPr>
-              <a:t>12. ENCABEZADO</a:t>
+              <a:t>- eventos N1/N2 usados en cada foco y los que quedaron fuera (p. ej., eventos aislados sin reiteración), con el motivo;</a:t>
             </a:r>
             <a:endParaRPr lang="en-US" sz="600" dirty="0"/>
           </a:p>
@@ -7495,7 +7971,7 @@
                 <a:ea typeface="Arial" pitchFamily="34" charset="-122"/>
                 <a:cs typeface="Arial" pitchFamily="34" charset="-120"/>
               </a:rPr>
-              <a:t>- Título: "ASSURANCE TURNO 1-3" o "ASSURANCE TURNO 2-4". Fecha/Período: "DD al DD MES". Turno: marca ☒ en el que corresponde.</a:t>
+              <a:t>- datos faltantes o inconsistentes y supuestos realizados.</a:t>
             </a:r>
             <a:endParaRPr lang="en-US" sz="600" dirty="0"/>
           </a:p>
@@ -7512,313 +7988,7 @@
                 <a:ea typeface="Arial" pitchFamily="34" charset="-122"/>
                 <a:cs typeface="Arial" pitchFamily="34" charset="-120"/>
               </a:rPr>
-              <a:t>- Inspector ITO, Proyecto/EECC y Área/Sector: complétalos solo si el usuario los entrega; si no, deja la línea en blanco.</a:t>
-            </a:r>
-            <a:endParaRPr lang="en-US" sz="600" dirty="0"/>
-          </a:p>
-          <a:p>
-            <a:pPr marL="0" indent="0">
-              <a:buNone/>
-            </a:pPr>
-            <a:r>
-              <a:rPr lang="en-US" sz="600" dirty="0">
-                <a:solidFill>
-                  <a:srgbClr val="222222"/>
-                </a:solidFill>
-                <a:latin typeface="Arial" pitchFamily="34" charset="0"/>
-                <a:ea typeface="Arial" pitchFamily="34" charset="-122"/>
-                <a:cs typeface="Arial" pitchFamily="34" charset="-120"/>
-              </a:rPr>
-              <a:t> </a:t>
-            </a:r>
-            <a:endParaRPr lang="en-US" sz="600" dirty="0"/>
-          </a:p>
-          <a:p>
-            <a:pPr marL="0" indent="0">
-              <a:buNone/>
-            </a:pPr>
-            <a:r>
-              <a:rPr lang="en-US" sz="600" dirty="0">
-                <a:solidFill>
-                  <a:srgbClr val="222222"/>
-                </a:solidFill>
-                <a:latin typeface="Arial" pitchFamily="34" charset="0"/>
-                <a:ea typeface="Arial" pitchFamily="34" charset="-122"/>
-                <a:cs typeface="Arial" pitchFamily="34" charset="-120"/>
-              </a:rPr>
-              <a:t>13. FORMATO (obligatorio)</a:t>
-            </a:r>
-            <a:endParaRPr lang="en-US" sz="600" dirty="0"/>
-          </a:p>
-          <a:p>
-            <a:pPr marL="0" indent="0">
-              <a:buNone/>
-            </a:pPr>
-            <a:r>
-              <a:rPr lang="en-US" sz="600" dirty="0">
-                <a:solidFill>
-                  <a:srgbClr val="222222"/>
-                </a:solidFill>
-                <a:latin typeface="Arial" pitchFamily="34" charset="0"/>
-                <a:ea typeface="Arial" pitchFamily="34" charset="-122"/>
-                <a:cs typeface="Arial" pitchFamily="34" charset="-120"/>
-              </a:rPr>
-              <a:t>- No cambies estructura, columnas, colores (salvo el de la celda de nivel según el punto 4), fuentes, íconos ni tamaño de la lámina.</a:t>
-            </a:r>
-            <a:endParaRPr lang="en-US" sz="600" dirty="0"/>
-          </a:p>
-          <a:p>
-            <a:pPr marL="0" indent="0">
-              <a:buNone/>
-            </a:pPr>
-            <a:r>
-              <a:rPr lang="en-US" sz="600" dirty="0">
-                <a:solidFill>
-                  <a:srgbClr val="222222"/>
-                </a:solidFill>
-                <a:latin typeface="Arial" pitchFamily="34" charset="0"/>
-                <a:ea typeface="Arial" pitchFamily="34" charset="-122"/>
-                <a:cs typeface="Arial" pitchFamily="34" charset="-120"/>
-              </a:rPr>
-              <a:t>- Reemplaza todo texto gris entre [corchetes] por contenido real en color de texto normal (negro, sin cursiva). No debe quedar ningún corchete, salvo [DATO FALTANTE] y las marcas de turno [T1-3]/[T2-4].</a:t>
-            </a:r>
-            <a:endParaRPr lang="en-US" sz="600" dirty="0"/>
-          </a:p>
-          <a:p>
-            <a:pPr marL="0" indent="0">
-              <a:buNone/>
-            </a:pPr>
-            <a:r>
-              <a:rPr lang="en-US" sz="600" dirty="0">
-                <a:solidFill>
-                  <a:srgbClr val="222222"/>
-                </a:solidFill>
-                <a:latin typeface="Arial" pitchFamily="34" charset="0"/>
-                <a:ea typeface="Arial" pitchFamily="34" charset="-122"/>
-                <a:cs typeface="Arial" pitchFamily="34" charset="-120"/>
-              </a:rPr>
-              <a:t>- Letra mínima 6 pt. Si el texto no cabe, resume; no reduzcas más la letra ni agrandes filas.</a:t>
-            </a:r>
-            <a:endParaRPr lang="en-US" sz="600" dirty="0"/>
-          </a:p>
-          <a:p>
-            <a:pPr marL="0" indent="0">
-              <a:buNone/>
-            </a:pPr>
-            <a:r>
-              <a:rPr lang="en-US" sz="600" dirty="0">
-                <a:solidFill>
-                  <a:srgbClr val="222222"/>
-                </a:solidFill>
-                <a:latin typeface="Arial" pitchFamily="34" charset="0"/>
-                <a:ea typeface="Arial" pitchFamily="34" charset="-122"/>
-                <a:cs typeface="Arial" pitchFamily="34" charset="-120"/>
-              </a:rPr>
-              <a:t>- Antes de entregar: elimina la lámina 2 (instructivo). No modifiques ni muevas el cuadro de texto oculto "Instrucciones IA" de la lámina 1.</a:t>
-            </a:r>
-            <a:endParaRPr lang="en-US" sz="600" dirty="0"/>
-          </a:p>
-          <a:p>
-            <a:pPr marL="0" indent="0">
-              <a:buNone/>
-            </a:pPr>
-            <a:r>
-              <a:rPr lang="en-US" sz="600" dirty="0">
-                <a:solidFill>
-                  <a:srgbClr val="222222"/>
-                </a:solidFill>
-                <a:latin typeface="Arial" pitchFamily="34" charset="0"/>
-                <a:ea typeface="Arial" pitchFamily="34" charset="-122"/>
-                <a:cs typeface="Arial" pitchFamily="34" charset="-120"/>
-              </a:rPr>
-              <a:t>- Nombre del archivo: ASSURANCE_TURNO_[1-3 o 2-4]_[DD-DD]_[MES].pptx (ej.: ASSURANCE_TURNO_1-3_07-20_SEP.pptx).</a:t>
-            </a:r>
-            <a:endParaRPr lang="en-US" sz="600" dirty="0"/>
-          </a:p>
-          <a:p>
-            <a:pPr marL="0" indent="0">
-              <a:buNone/>
-            </a:pPr>
-            <a:r>
-              <a:rPr lang="en-US" sz="600" dirty="0">
-                <a:solidFill>
-                  <a:srgbClr val="222222"/>
-                </a:solidFill>
-                <a:latin typeface="Arial" pitchFamily="34" charset="0"/>
-                <a:ea typeface="Arial" pitchFamily="34" charset="-122"/>
-                <a:cs typeface="Arial" pitchFamily="34" charset="-120"/>
-              </a:rPr>
-              <a:t> </a:t>
-            </a:r>
-            <a:endParaRPr lang="en-US" sz="600" dirty="0"/>
-          </a:p>
-          <a:p>
-            <a:pPr marL="0" indent="0">
-              <a:buNone/>
-            </a:pPr>
-            <a:r>
-              <a:rPr lang="en-US" sz="600" dirty="0">
-                <a:solidFill>
-                  <a:srgbClr val="222222"/>
-                </a:solidFill>
-                <a:latin typeface="Arial" pitchFamily="34" charset="0"/>
-                <a:ea typeface="Arial" pitchFamily="34" charset="-122"/>
-                <a:cs typeface="Arial" pitchFamily="34" charset="-120"/>
-              </a:rPr>
-              <a:t>14. ENTREGA</a:t>
-            </a:r>
-            <a:endParaRPr lang="en-US" sz="600" dirty="0"/>
-          </a:p>
-          <a:p>
-            <a:pPr marL="0" indent="0">
-              <a:buNone/>
-            </a:pPr>
-            <a:r>
-              <a:rPr lang="en-US" sz="600" dirty="0">
-                <a:solidFill>
-                  <a:srgbClr val="222222"/>
-                </a:solidFill>
-                <a:latin typeface="Arial" pitchFamily="34" charset="0"/>
-                <a:ea typeface="Arial" pitchFamily="34" charset="-122"/>
-                <a:cs typeface="Arial" pitchFamily="34" charset="-120"/>
-              </a:rPr>
-              <a:t>- Si puedes editar archivos .pptx: entrega el archivo completado.</a:t>
-            </a:r>
-            <a:endParaRPr lang="en-US" sz="600" dirty="0"/>
-          </a:p>
-          <a:p>
-            <a:pPr marL="0" indent="0">
-              <a:buNone/>
-            </a:pPr>
-            <a:r>
-              <a:rPr lang="en-US" sz="600" dirty="0">
-                <a:solidFill>
-                  <a:srgbClr val="222222"/>
-                </a:solidFill>
-                <a:latin typeface="Arial" pitchFamily="34" charset="0"/>
-                <a:ea typeface="Arial" pitchFamily="34" charset="-122"/>
-                <a:cs typeface="Arial" pitchFamily="34" charset="-120"/>
-              </a:rPr>
-              <a:t>- Si no puedes: entrega el contenido en texto, ordenado por sección y por fila de la plantilla (Encabezado; Indicadores 14 días; Focos 1 a 4 con sus 5 columnas; Fila 5 SI PRO; Recurrente; Bloques AM/Mediodía/PM; Tendencias no asociadas; Tendencias asociadas a controles críticos), listo para copiar y pegar en cada casilla.</a:t>
-            </a:r>
-            <a:endParaRPr lang="en-US" sz="600" dirty="0"/>
-          </a:p>
-          <a:p>
-            <a:pPr marL="0" indent="0">
-              <a:buNone/>
-            </a:pPr>
-            <a:r>
-              <a:rPr lang="en-US" sz="600" dirty="0">
-                <a:solidFill>
-                  <a:srgbClr val="222222"/>
-                </a:solidFill>
-                <a:latin typeface="Arial" pitchFamily="34" charset="0"/>
-                <a:ea typeface="Arial" pitchFamily="34" charset="-122"/>
-                <a:cs typeface="Arial" pitchFamily="34" charset="-120"/>
-              </a:rPr>
-              <a:t> </a:t>
-            </a:r>
-            <a:endParaRPr lang="en-US" sz="600" dirty="0"/>
-          </a:p>
-          <a:p>
-            <a:pPr marL="0" indent="0">
-              <a:buNone/>
-            </a:pPr>
-            <a:r>
-              <a:rPr lang="en-US" sz="600" dirty="0">
-                <a:solidFill>
-                  <a:srgbClr val="222222"/>
-                </a:solidFill>
-                <a:latin typeface="Arial" pitchFamily="34" charset="0"/>
-                <a:ea typeface="Arial" pitchFamily="34" charset="-122"/>
-                <a:cs typeface="Arial" pitchFamily="34" charset="-120"/>
-              </a:rPr>
-              <a:t>15. CONTROL DE CALIDAD (en tu respuesta al usuario, no dentro del archivo)</a:t>
-            </a:r>
-            <a:endParaRPr lang="en-US" sz="600" dirty="0"/>
-          </a:p>
-          <a:p>
-            <a:pPr marL="0" indent="0">
-              <a:buNone/>
-            </a:pPr>
-            <a:r>
-              <a:rPr lang="en-US" sz="600" dirty="0">
-                <a:solidFill>
-                  <a:srgbClr val="222222"/>
-                </a:solidFill>
-                <a:latin typeface="Arial" pitchFamily="34" charset="0"/>
-                <a:ea typeface="Arial" pitchFamily="34" charset="-122"/>
-                <a:cs typeface="Arial" pitchFamily="34" charset="-120"/>
-              </a:rPr>
-              <a:t>Al final de tu respuesta incluye un resumen breve con:</a:t>
-            </a:r>
-            <a:endParaRPr lang="en-US" sz="600" dirty="0"/>
-          </a:p>
-          <a:p>
-            <a:pPr marL="0" indent="0">
-              <a:buNone/>
-            </a:pPr>
-            <a:r>
-              <a:rPr lang="en-US" sz="600" dirty="0">
-                <a:solidFill>
-                  <a:srgbClr val="222222"/>
-                </a:solidFill>
-                <a:latin typeface="Arial" pitchFamily="34" charset="0"/>
-                <a:ea typeface="Arial" pitchFamily="34" charset="-122"/>
-                <a:cs typeface="Arial" pitchFamily="34" charset="-120"/>
-              </a:rPr>
-              <a:t>- total de eventos leídos del período y cuántos de cada tipo (ACC, CAAP, HAP, CBP, HBP);</a:t>
-            </a:r>
-            <a:endParaRPr lang="en-US" sz="600" dirty="0"/>
-          </a:p>
-          <a:p>
-            <a:pPr marL="0" indent="0">
-              <a:buNone/>
-            </a:pPr>
-            <a:r>
-              <a:rPr lang="en-US" sz="600" dirty="0">
-                <a:solidFill>
-                  <a:srgbClr val="222222"/>
-                </a:solidFill>
-                <a:latin typeface="Arial" pitchFamily="34" charset="0"/>
-                <a:ea typeface="Arial" pitchFamily="34" charset="-122"/>
-                <a:cs typeface="Arial" pitchFamily="34" charset="-120"/>
-              </a:rPr>
-              <a:t>- eventos N1/N2 usados en cada foco y los que quedaron fuera, con el motivo;</a:t>
-            </a:r>
-            <a:endParaRPr lang="en-US" sz="600" dirty="0"/>
-          </a:p>
-          <a:p>
-            <a:pPr marL="0" indent="0">
-              <a:buNone/>
-            </a:pPr>
-            <a:r>
-              <a:rPr lang="en-US" sz="600" dirty="0">
-                <a:solidFill>
-                  <a:srgbClr val="222222"/>
-                </a:solidFill>
-                <a:latin typeface="Arial" pitchFamily="34" charset="0"/>
-                <a:ea typeface="Arial" pitchFamily="34" charset="-122"/>
-                <a:cs typeface="Arial" pitchFamily="34" charset="-120"/>
-              </a:rPr>
-              <a:t>- datos faltantes o inconsistentes y supuestos realizados.</a:t>
-            </a:r>
-            <a:endParaRPr lang="en-US" sz="600" dirty="0"/>
-          </a:p>
-          <a:p>
-            <a:pPr marL="0" indent="0">
-              <a:buNone/>
-            </a:pPr>
-            <a:r>
-              <a:rPr lang="en-US" sz="600" dirty="0">
-                <a:solidFill>
-                  <a:srgbClr val="222222"/>
-                </a:solidFill>
-                <a:latin typeface="Arial" pitchFamily="34" charset="0"/>
-                <a:ea typeface="Arial" pitchFamily="34" charset="-122"/>
-                <a:cs typeface="Arial" pitchFamily="34" charset="-120"/>
-              </a:rPr>
-              <a:t>Antes de entregar, confirma que: cada ID existe en el Excel; ningún HBP aparece como foco o evento de origen; cada foco tiene al menos un evento de origen; los conteos de indicadores y Recurrente cuadran; y no quedan textos guía.</a:t>
+              <a:t>Antes de entregar, confirma que: cada ID existe en el Excel; cada foco tiene al menos 2 eventos N1/N2 relacionados; el nivel y el orden de los focos siguen la tabla de prioridad; ningún HBP aparece como foco o evento de origen; los conteos de indicadores y Recurrente cuadran; y no quedan textos guía.</a:t>
             </a:r>
             <a:endParaRPr lang="en-US" sz="600" dirty="0"/>
           </a:p>
@@ -8480,7 +8650,7 @@
                 <a:ea typeface="Arial" pitchFamily="34" charset="-122"/>
                 <a:cs typeface="Arial" pitchFamily="34" charset="-120"/>
               </a:rPr>
-              <a:t>SELECCIÓN DE FOCOS</a:t>
+              <a:t>SELECCIÓN DE FOCOS · REITERACIÓN</a:t>
             </a:r>
             <a:endParaRPr lang="en-US" sz="1050" dirty="0"/>
           </a:p>
@@ -8519,7 +8689,7 @@
                 <a:ea typeface="Arial" pitchFamily="34" charset="-122"/>
                 <a:cs typeface="Arial" pitchFamily="34" charset="-120"/>
               </a:rPr>
-              <a:t>Solo eventos N1 y N2 de los últimos 14 días (ACC, CAAP, HAP, CBP). Un foco = un riesgo: agrupar los eventos del mismo riesgo. Máx. 4 focos (filas 1 a 4). Los HBP (N3) no ingresan como foco.</a:t>
+              <a:t>Un foco se crea solo si 2 o más eventos N1/N2 (ACC, CAAP, HAP, CBP) de los últimos 14 días se repiten en un mismo tema (ej.: izaje). Un evento aislado no genera foco. Máx. 4 focos; los HBP (N3) no cuentan.</a:t>
             </a:r>
             <a:endParaRPr lang="en-US" sz="930" dirty="0"/>
           </a:p>
@@ -8663,7 +8833,7 @@
                 <a:ea typeface="Arial" pitchFamily="34" charset="-122"/>
                 <a:cs typeface="Arial" pitchFamily="34" charset="-120"/>
               </a:rPr>
-              <a:t>NIVEL / PRIORIDAD</a:t>
+              <a:t>NIVEL Y PRIORIDAD</a:t>
             </a:r>
             <a:endParaRPr lang="en-US" sz="1050" dirty="0"/>
           </a:p>
@@ -8702,7 +8872,7 @@
                 <a:ea typeface="Arial" pitchFamily="34" charset="-122"/>
                 <a:cs typeface="Arial" pitchFamily="34" charset="-120"/>
               </a:rPr>
-              <a:t>N° + nivel del evento más grave. N1 · Criticidad alta (roja): accidentes con lesión o daño material y CAAP. N2 · Criticidad intermedia (naranja): CBP y HAP. Ordenar N1 → N2. Color: clic en la celda › Diseño de tabla › Sombreado.</a:t>
+              <a:t>Prioridad por tipo: 1 ACC con lesión · 2 ACC daño material · 3 CAAP (N1, roja) · 4 CBP · 5 HAP (N2, naranja). Nivel del foco = su evento de mayor prioridad. Orden: N1 → N2; empate: más eventos, luego más reciente.</a:t>
             </a:r>
             <a:endParaRPr lang="en-US" sz="930" dirty="0"/>
           </a:p>
@@ -8846,7 +9016,7 @@
                 <a:ea typeface="Arial" pitchFamily="34" charset="-122"/>
                 <a:cs typeface="Arial" pitchFamily="34" charset="-120"/>
               </a:rPr>
-              <a:t>FOCO DE ASSURANCE</a:t>
+              <a:t>FOCO · INSTRUCCIÓN ESPECÍFICA</a:t>
             </a:r>
             <a:endParaRPr lang="en-US" sz="1050" dirty="0"/>
           </a:p>
@@ -8885,7 +9055,7 @@
                 <a:ea typeface="Arial" pitchFamily="34" charset="-122"/>
                 <a:cs typeface="Arial" pitchFamily="34" charset="-120"/>
               </a:rPr>
-              <a:t>Tema en negrita + instrucción que parte con verbo ("Verificar…"): qué, dónde y bajo qué estándar (máx. 3 líneas). Cerrar con "Criterio de restricción": cuándo se prohíbe o se detiene la tarea (máx. 2 líneas).</a:t>
+              <a:t>Instrucción para el turno entrante: dónde (área/frente), qué actividad o equipo, qué control verificar, quién y cuándo. Evitar lo general ("izar de forma segura"). Cerrar con "Criterio de restricción".</a:t>
             </a:r>
             <a:endParaRPr lang="en-US" sz="930" dirty="0"/>
           </a:p>
@@ -9068,7 +9238,7 @@
                 <a:ea typeface="Arial" pitchFamily="34" charset="-122"/>
                 <a:cs typeface="Arial" pitchFamily="34" charset="-120"/>
               </a:rPr>
-              <a:t>Formato fijo: [Turno] TIPO ID – EECC: qué ocurrió.</a:t>
+              <a:t>Todos los eventos N1/N2 del tema que originan el foco (mín. 2), ordenados por prioridad. Formato: [Turno] TIPO ID – EECC: qué ocurrió.</a:t>
             </a:r>
             <a:endParaRPr lang="en-US" sz="930" dirty="0"/>
           </a:p>
@@ -9085,24 +9255,7 @@
                 <a:ea typeface="Arial" pitchFamily="34" charset="-122"/>
                 <a:cs typeface="Arial" pitchFamily="34" charset="-120"/>
               </a:rPr>
-              <a:t>Ej.: [T1-3] HAP 553767 – JEJ: camioneta con neumático dañado.</a:t>
-            </a:r>
-            <a:endParaRPr lang="en-US" sz="930" dirty="0"/>
-          </a:p>
-          <a:p>
-            <a:pPr marL="0" indent="0">
-              <a:buNone/>
-            </a:pPr>
-            <a:r>
-              <a:rPr lang="en-US" sz="930" dirty="0">
-                <a:solidFill>
-                  <a:srgbClr val="222222"/>
-                </a:solidFill>
-                <a:latin typeface="Arial" pitchFamily="34" charset="0"/>
-                <a:ea typeface="Arial" pitchFamily="34" charset="-122"/>
-                <a:cs typeface="Arial" pitchFamily="34" charset="-120"/>
-              </a:rPr>
-              <a:t>Máx. 3 eventos por foco, 1–2 líneas cada uno.</a:t>
+              <a:t>Ej.: [T1-3] CAAP 555505 – PUMA: plan de izaje no corresponde a la carga.</a:t>
             </a:r>
             <a:endParaRPr lang="en-US" sz="930" dirty="0"/>
           </a:p>
@@ -10251,7 +10404,7 @@
                 <a:ea typeface="Arial" pitchFamily="34" charset="-122"/>
                 <a:cs typeface="Arial" pitchFamily="34" charset="-120"/>
               </a:rPr>
-              <a:t>Fila fija: estrategia de controles según la Directriz GSSO vigente, herramienta GCC y registro en QR o plataforma PASSO (Gerencia SSO). No se reemplaza por eventos ni se elimina.</a:t>
+              <a:t>Fila fija por ahora: estrategia de controles según Directriz GSSO, herramienta GCC y registro en QR o plataforma PASSO (Gerencia SSO). No se completa, no se modifica ni se elimina hasta recibir la directriz.</a:t>
             </a:r>
             <a:endParaRPr lang="en-US" sz="930" dirty="0"/>
           </a:p>
@@ -10525,7 +10678,7 @@
               <a:buChar char="•"/>
             </a:pPr>
             <a:r>
-              <a:rPr lang="en-US" sz="780" dirty="0" b="1">
+              <a:rPr lang="en-US" sz="760" dirty="0" b="1">
                 <a:solidFill>
                   <a:srgbClr val="C62828"/>
                 </a:solidFill>
@@ -10536,15 +10689,15 @@
               <a:t>N1 · Criticidad alta: </a:t>
             </a:r>
             <a:r>
-              <a:rPr lang="en-US" sz="780" dirty="0">
-                <a:solidFill>
-                  <a:srgbClr val="222222"/>
-                </a:solidFill>
-                <a:latin typeface="Arial" pitchFamily="34" charset="0"/>
-                <a:ea typeface="Arial" pitchFamily="34" charset="-122"/>
-                <a:cs typeface="Arial" pitchFamily="34" charset="-120"/>
-              </a:rPr>
-              <a:t>riesgo con potencial de consecuencias graves o fatales; intervención y gestión prioritaria. Accidentes con lesión o daño material y CAAP.</a:t>
+              <a:rPr lang="en-US" sz="760" dirty="0" b="0">
+                <a:solidFill>
+                  <a:srgbClr val="222222"/>
+                </a:solidFill>
+                <a:latin typeface="Arial" pitchFamily="34" charset="0"/>
+                <a:ea typeface="Arial" pitchFamily="34" charset="-122"/>
+                <a:cs typeface="Arial" pitchFamily="34" charset="-120"/>
+              </a:rPr>
+              <a:t>consecuencias graves o fatales; gestión prioritaria. Prioridad: 1 ACC con lesión · 2 ACC daño material · 3 CAAP.</a:t>
             </a:r>
             <a:endParaRPr lang="en-US" sz="930" dirty="0"/>
           </a:p>
@@ -10557,7 +10710,7 @@
               <a:buChar char="•"/>
             </a:pPr>
             <a:r>
-              <a:rPr lang="en-US" sz="780" dirty="0" b="1">
+              <a:rPr lang="en-US" sz="760" dirty="0" b="1">
                 <a:solidFill>
                   <a:srgbClr val="B35C00"/>
                 </a:solidFill>
@@ -10568,15 +10721,15 @@
               <a:t>N2 · Criticidad intermedia: </a:t>
             </a:r>
             <a:r>
-              <a:rPr lang="en-US" sz="780" dirty="0">
-                <a:solidFill>
-                  <a:srgbClr val="222222"/>
-                </a:solidFill>
-                <a:latin typeface="Arial" pitchFamily="34" charset="0"/>
-                <a:ea typeface="Arial" pitchFamily="34" charset="-122"/>
-                <a:cs typeface="Arial" pitchFamily="34" charset="-120"/>
-              </a:rPr>
-              <a:t>requiere gestión y seguimiento. CBP (interacción próxima persona–situación) y HAP (controles críticos no implementados o erosionados, antes de la interacción).</a:t>
+              <a:rPr lang="en-US" sz="760" dirty="0" b="0">
+                <a:solidFill>
+                  <a:srgbClr val="222222"/>
+                </a:solidFill>
+                <a:latin typeface="Arial" pitchFamily="34" charset="0"/>
+                <a:ea typeface="Arial" pitchFamily="34" charset="-122"/>
+                <a:cs typeface="Arial" pitchFamily="34" charset="-120"/>
+              </a:rPr>
+              <a:t>gestión y seguimiento. Prioridad: 4 CBP (interacción próxima persona–situación) · 5 HAP (control crítico no implementado o erosionado).</a:t>
             </a:r>
             <a:endParaRPr lang="en-US" sz="930" dirty="0"/>
           </a:p>
@@ -10589,7 +10742,7 @@
               <a:buChar char="•"/>
             </a:pPr>
             <a:r>
-              <a:rPr lang="en-US" sz="780" dirty="0" b="1">
+              <a:rPr lang="en-US" sz="760" dirty="0" b="1">
                 <a:solidFill>
                   <a:srgbClr val="222222"/>
                 </a:solidFill>
@@ -10600,15 +10753,47 @@
               <a:t>N3 · HBP: </a:t>
             </a:r>
             <a:r>
-              <a:rPr lang="en-US" sz="780" dirty="0">
-                <a:solidFill>
-                  <a:srgbClr val="222222"/>
-                </a:solidFill>
-                <a:latin typeface="Arial" pitchFamily="34" charset="0"/>
-                <a:ea typeface="Arial" pitchFamily="34" charset="-122"/>
-                <a:cs typeface="Arial" pitchFamily="34" charset="-120"/>
-              </a:rPr>
-              <a:t>menor criticidad; corrección inmediata o gestión directa en terreno. No ingresa al Assurance (solo en Recurrente).</a:t>
+              <a:rPr lang="en-US" sz="760" dirty="0" b="0">
+                <a:solidFill>
+                  <a:srgbClr val="222222"/>
+                </a:solidFill>
+                <a:latin typeface="Arial" pitchFamily="34" charset="0"/>
+                <a:ea typeface="Arial" pitchFamily="34" charset="-122"/>
+                <a:cs typeface="Arial" pitchFamily="34" charset="-120"/>
+              </a:rPr>
+              <a:t>corrección inmediata en terreno; no ingresa como foco (solo Recurrente).</a:t>
+            </a:r>
+            <a:endParaRPr lang="en-US" sz="930" dirty="0"/>
+          </a:p>
+          <a:p>
+            <a:pPr marL="152400" indent="-152400">
+              <a:spcAft>
+                <a:spcPts val="200"/>
+              </a:spcAft>
+              <a:buSzPct val="100000"/>
+              <a:buChar char="•"/>
+            </a:pPr>
+            <a:r>
+              <a:rPr lang="en-US" sz="760" dirty="0" b="1">
+                <a:solidFill>
+                  <a:srgbClr val="1F3D6B"/>
+                </a:solidFill>
+                <a:latin typeface="Arial" pitchFamily="34" charset="0"/>
+                <a:ea typeface="Arial" pitchFamily="34" charset="-122"/>
+                <a:cs typeface="Arial" pitchFamily="34" charset="-120"/>
+              </a:rPr>
+              <a:t>Foco = reiteración: </a:t>
+            </a:r>
+            <a:r>
+              <a:rPr lang="en-US" sz="760" dirty="0" b="0">
+                <a:solidFill>
+                  <a:srgbClr val="222222"/>
+                </a:solidFill>
+                <a:latin typeface="Arial" pitchFamily="34" charset="0"/>
+                <a:ea typeface="Arial" pitchFamily="34" charset="-122"/>
+                <a:cs typeface="Arial" pitchFamily="34" charset="-120"/>
+              </a:rPr>
+              <a:t>2 o más eventos N1/N2 del mismo tema en 14 días.</a:t>
             </a:r>
             <a:endParaRPr lang="en-US" sz="930" dirty="0"/>
           </a:p>

</xml_diff>

<commit_message>
Formato Assurance ITO v1.1: ACC o CAAP aislado como foco de menor prioridad
Co-Authored-By: Claude Opus 5.5 <noreply@anthropic.com>
Claude-Session: https://claude.ai/code/session_017MaLNPnWzNhW9Tdfmjv67V
</commit_message>
<xml_diff>
--- a/FORMATO_ASSURANCE_ITO_v1.1.pptx
+++ b/FORMATO_ASSURANCE_ITO_v1.1.pptx
@@ -6798,7 +6798,7 @@
                 <a:ea typeface="Arial" pitchFamily="34" charset="-122"/>
                 <a:cs typeface="Arial" pitchFamily="34" charset="-120"/>
               </a:rPr>
-              <a:t>- Un foco solo se crea cuando hay REITERACIÓN: 2 o más eventos N1/N2 (ACC, CAAP, HAP, CBP) del período relacionados con un mismo tema (p. ej.: izaje, trabajo en altura/andamios, vehículos y equipos, energía eléctrica, excavaciones/zanjas). Un evento aislado, aunque sea N1, NO genera foco: menciónalo al usuario en el control de calidad.</a:t>
+              <a:t>- Un foco solo se crea cuando hay REITERACIÓN: 2 o más eventos N1/N2 (ACC, CAAP, HAP, CBP) del período relacionados con un mismo tema (p. ej.: izaje, trabajo en altura/andamios, vehículos y equipos, energía eléctrica, excavaciones/zanjas). Excepción – N1 aislado: un ACC o CAAP sin reiteración SÍ se incluye como foco, pero con menor prioridad que todos los focos por reiteración (ver punto 4). Un N2 aislado (CBP o HAP sin reiteración) NO genera foco: menciónalo al usuario en el control de calidad.</a:t>
             </a:r>
             <a:endParaRPr lang="en-US" sz="600" dirty="0"/>
           </a:p>
@@ -7036,7 +7036,7 @@
                 <a:ea typeface="Arial" pitchFamily="34" charset="-122"/>
                 <a:cs typeface="Arial" pitchFamily="34" charset="-120"/>
               </a:rPr>
-              <a:t>- Orden de los focos: primero todos los N1 y luego los N2. Dentro del mismo nivel: (a) el evento de mayor prioridad según la tabla, (b) mayor cantidad de eventos reiterados, (c) evento más reciente.</a:t>
+              <a:t>- Orden de los focos: (1) focos por reiteración N1, (2) focos por reiteración N2, (3) focos por N1 aislado (ACC o CAAP sin reiteración), al final. Dentro de cada grupo: (a) el evento de mayor prioridad según la tabla, (b) mayor cantidad de eventos, (c) evento más reciente.</a:t>
             </a:r>
             <a:endParaRPr lang="en-US" sz="600" dirty="0"/>
           </a:p>
@@ -7053,6 +7053,23 @@
                 <a:ea typeface="Arial" pitchFamily="34" charset="-122"/>
                 <a:cs typeface="Arial" pitchFamily="34" charset="-120"/>
               </a:rPr>
+              <a:t>- Un foco por N1 aislado mantiene el nivel N1 (celda roja), aunque vaya al final del orden.</a:t>
+            </a:r>
+            <a:endParaRPr lang="en-US" sz="600" dirty="0"/>
+          </a:p>
+          <a:p>
+            <a:pPr marL="0" indent="0">
+              <a:buNone/>
+            </a:pPr>
+            <a:r>
+              <a:rPr lang="en-US" sz="600" dirty="0">
+                <a:solidFill>
+                  <a:srgbClr val="222222"/>
+                </a:solidFill>
+                <a:latin typeface="Arial" pitchFamily="34" charset="0"/>
+                <a:ea typeface="Arial" pitchFamily="34" charset="-122"/>
+                <a:cs typeface="Arial" pitchFamily="34" charset="-120"/>
+              </a:rPr>
               <a:t>- Texto de la celda: número del foco + "N1 · CRITICIDAD ALTA" o "N2 · CRITICIDAD INTERMEDIA". Color: N1 = rojo C62828; N2 = naranja E67E22. Ajusta texto y color de cada fila al nivel real (la plantilla trae 3 filas N1 y 1 N2 solo como referencia).</a:t>
             </a:r>
             <a:endParaRPr lang="en-US" sz="600" dirty="0"/>
@@ -7291,7 +7308,7 @@
                 <a:ea typeface="Arial" pitchFamily="34" charset="-122"/>
                 <a:cs typeface="Arial" pitchFamily="34" charset="-120"/>
               </a:rPr>
-              <a:t>- Lista TODOS los eventos N1/N2 del período que originan el foco (mínimo 2, por la regla de reiteración), ordenados según la tabla de prioridad del punto 4. Si son más de 4, lista los 4 de mayor prioridad y agrega "+ N eventos más".</a:t>
+              <a:t>- Lista TODOS los eventos N1/N2 del período que originan el foco (mínimo 2 en focos por reiteración; 1 en focos por N1 aislado, agregando al final "(evento aislado)"), ordenados según la tabla de prioridad del punto 4. Si son más de 4, lista los 4 de mayor prioridad y agrega "+ N eventos más".</a:t>
             </a:r>
             <a:endParaRPr lang="en-US" sz="600" dirty="0"/>
           </a:p>
@@ -7954,7 +7971,7 @@
                 <a:ea typeface="Arial" pitchFamily="34" charset="-122"/>
                 <a:cs typeface="Arial" pitchFamily="34" charset="-120"/>
               </a:rPr>
-              <a:t>- eventos N1/N2 usados en cada foco y los que quedaron fuera (p. ej., eventos aislados sin reiteración), con el motivo;</a:t>
+              <a:t>- eventos N1/N2 usados en cada foco y los que quedaron fuera (p. ej., CBP o HAP aislados sin reiteración), con el motivo;</a:t>
             </a:r>
             <a:endParaRPr lang="en-US" sz="600" dirty="0"/>
           </a:p>
@@ -7988,7 +8005,7 @@
                 <a:ea typeface="Arial" pitchFamily="34" charset="-122"/>
                 <a:cs typeface="Arial" pitchFamily="34" charset="-120"/>
               </a:rPr>
-              <a:t>Antes de entregar, confirma que: cada ID existe en el Excel; cada foco tiene al menos 2 eventos N1/N2 relacionados; el nivel y el orden de los focos siguen la tabla de prioridad; ningún HBP aparece como foco o evento de origen; los conteos de indicadores y Recurrente cuadran; y no quedan textos guía.</a:t>
+              <a:t>Antes de entregar, confirma que: cada ID existe en el Excel; cada foco tiene al menos 2 eventos N1/N2 relacionados, salvo los focos por N1 aislado, que van al final; el nivel y el orden de los focos siguen la tabla de prioridad; ningún HBP aparece como foco o evento de origen; los conteos de indicadores y Recurrente cuadran; y no quedan textos guía.</a:t>
             </a:r>
             <a:endParaRPr lang="en-US" sz="600" dirty="0"/>
           </a:p>
@@ -8689,7 +8706,7 @@
                 <a:ea typeface="Arial" pitchFamily="34" charset="-122"/>
                 <a:cs typeface="Arial" pitchFamily="34" charset="-120"/>
               </a:rPr>
-              <a:t>Un foco se crea solo si 2 o más eventos N1/N2 (ACC, CAAP, HAP, CBP) de los últimos 14 días se repiten en un mismo tema (ej.: izaje). Un evento aislado no genera foco. Máx. 4 focos; los HBP (N3) no cuentan.</a:t>
+              <a:t>Un foco se crea solo si 2 o más eventos N1/N2 (ACC, CAAP, HAP, CBP) de los últimos 14 días se repiten en un mismo tema (ej.: izaje). Un ACC o CAAP aislado también es foco, pero al final. CBP/HAP aislados no. Máx. 4 focos; HBP no cuentan.</a:t>
             </a:r>
             <a:endParaRPr lang="en-US" sz="930" dirty="0"/>
           </a:p>
@@ -8872,7 +8889,7 @@
                 <a:ea typeface="Arial" pitchFamily="34" charset="-122"/>
                 <a:cs typeface="Arial" pitchFamily="34" charset="-120"/>
               </a:rPr>
-              <a:t>Prioridad por tipo: 1 ACC con lesión · 2 ACC daño material · 3 CAAP (N1, roja) · 4 CBP · 5 HAP (N2, naranja). Nivel del foco = su evento de mayor prioridad. Orden: N1 → N2; empate: más eventos, luego más reciente.</a:t>
+              <a:t>Prioridad por tipo: 1 ACC con lesión · 2 ACC daño material · 3 CAAP (N1, roja) · 4 CBP · 5 HAP (N2, naranja). Nivel = su evento de mayor prioridad. Orden: reiterados N1 → reiterados N2 → N1 aislados; empate: más eventos, más reciente.</a:t>
             </a:r>
             <a:endParaRPr lang="en-US" sz="930" dirty="0"/>
           </a:p>
@@ -9238,7 +9255,7 @@
                 <a:ea typeface="Arial" pitchFamily="34" charset="-122"/>
                 <a:cs typeface="Arial" pitchFamily="34" charset="-120"/>
               </a:rPr>
-              <a:t>Todos los eventos N1/N2 del tema que originan el foco (mín. 2), ordenados por prioridad. Formato: [Turno] TIPO ID – EECC: qué ocurrió.</a:t>
+              <a:t>Todos los eventos N1/N2 del tema que originan el foco (mín. 2; N1 aislado: 1, con "(evento aislado)"), ordenados por prioridad. Formato: [Turno] TIPO ID – EECC: qué ocurrió.</a:t>
             </a:r>
             <a:endParaRPr lang="en-US" sz="930" dirty="0"/>
           </a:p>
@@ -10793,7 +10810,7 @@
                 <a:ea typeface="Arial" pitchFamily="34" charset="-122"/>
                 <a:cs typeface="Arial" pitchFamily="34" charset="-120"/>
               </a:rPr>
-              <a:t>2 o más eventos N1/N2 del mismo tema en 14 días.</a:t>
+              <a:t>2 o más eventos N1/N2 del mismo tema en 14 días. ACC o CAAP aislado: foco de menor prioridad.</a:t>
             </a:r>
             <a:endParaRPr lang="en-US" sz="930" dirty="0"/>
           </a:p>

</xml_diff>

<commit_message>
Formato Assurance ITO v1.1: separar nivel y prioridad; incluir focos aislados N2
- Nivel (N1/N2) = criticidad por tipo de evento, define el color.
- Prioridad = orden del foco: reiterados N1, reiterados N2, aislados N1, aislados N2.

Co-Authored-By: Claude Opus 5.5 <noreply@anthropic.com>
Claude-Session: https://claude.ai/code/session_017MaLNPnWzNhW9Tdfmjv67V
</commit_message>
<xml_diff>
--- a/FORMATO_ASSURANCE_ITO_v1.1.pptx
+++ b/FORMATO_ASSURANCE_ITO_v1.1.pptx
@@ -6781,7 +6781,7 @@
                 <a:ea typeface="Arial" pitchFamily="34" charset="-122"/>
                 <a:cs typeface="Arial" pitchFamily="34" charset="-120"/>
               </a:rPr>
-              <a:t>3. SELECCIÓN DE FOCOS (filas 1 a 4) – REGLA DE REITERACIÓN</a:t>
+              <a:t>3. SELECCIÓN DE FOCOS (filas 1 a 4)</a:t>
             </a:r>
             <a:endParaRPr lang="en-US" sz="600" dirty="0"/>
           </a:p>
@@ -6798,7 +6798,7 @@
                 <a:ea typeface="Arial" pitchFamily="34" charset="-122"/>
                 <a:cs typeface="Arial" pitchFamily="34" charset="-120"/>
               </a:rPr>
-              <a:t>- Un foco solo se crea cuando hay REITERACIÓN: 2 o más eventos N1/N2 (ACC, CAAP, HAP, CBP) del período relacionados con un mismo tema (p. ej.: izaje, trabajo en altura/andamios, vehículos y equipos, energía eléctrica, excavaciones/zanjas). Excepción – N1 aislado: un ACC o CAAP sin reiteración SÍ se incluye como foco, pero con menor prioridad que todos los focos por reiteración (ver punto 4). Un N2 aislado (CBP o HAP sin reiteración) NO genera foco: menciónalo al usuario en el control de calidad.</a:t>
+              <a:t>- Solo eventos N1 y N2 del período (ACC, CAAP, HAP, CBP). Nunca uses HBP (N3) como foco ni para contar reiteración.</a:t>
             </a:r>
             <a:endParaRPr lang="en-US" sz="600" dirty="0"/>
           </a:p>
@@ -6815,7 +6815,7 @@
                 <a:ea typeface="Arial" pitchFamily="34" charset="-122"/>
                 <a:cs typeface="Arial" pitchFamily="34" charset="-120"/>
               </a:rPr>
-              <a:t>- Para agrupar por tema usa "RIESGO INVOLUCRADO" y también "Titulo" y "Descripción": muchos eventos dicen "Otro riesgo de seguridad" pero pertenecen a un tema (p. ej., un CBP por retiro de eslinga pertenece a izaje).</a:t>
+              <a:t>- Agrupa los eventos por tema (p. ej.: izaje, trabajo en altura/andamios, vehículos y equipos, energía eléctrica, excavaciones/zanjas). Usa "RIESGO INVOLUCRADO" y también "Titulo" y "Descripción": muchos eventos dicen "Otro riesgo de seguridad" pero pertenecen a un tema (p. ej., un CBP por retiro de eslinga pertenece a izaje).</a:t>
             </a:r>
             <a:endParaRPr lang="en-US" sz="600" dirty="0"/>
           </a:p>
@@ -6832,7 +6832,7 @@
                 <a:ea typeface="Arial" pitchFamily="34" charset="-122"/>
                 <a:cs typeface="Arial" pitchFamily="34" charset="-120"/>
               </a:rPr>
-              <a:t>- Nunca uses HBP (N3) como foco ni para contar reiteración.</a:t>
+              <a:t>- Foco REITERADO: tema con 2 o más eventos N1/N2 en el período.</a:t>
             </a:r>
             <a:endParaRPr lang="en-US" sz="600" dirty="0"/>
           </a:p>
@@ -6849,7 +6849,7 @@
                 <a:ea typeface="Arial" pitchFamily="34" charset="-122"/>
                 <a:cs typeface="Arial" pitchFamily="34" charset="-120"/>
               </a:rPr>
-              <a:t>- Máximo 4 focos. Si hay más temas reiterados, deja fuera los de menor prioridad e infórmalo. Si hay menos, elimina las filas sobrantes (nunca la fila 5). Si no hay ninguna reiteración, deja solo la fila 5 e infórmalo.</a:t>
+              <a:t>- Foco AISLADO: tema con un solo evento N1/N2 en el período. Los focos aislados SÍ se incluyen (sean ACC, CAAP, CBP o HAP), pero siempre después de todos los focos reiterados (ver punto 4).</a:t>
             </a:r>
             <a:endParaRPr lang="en-US" sz="600" dirty="0"/>
           </a:p>
@@ -6866,6 +6866,23 @@
                 <a:ea typeface="Arial" pitchFamily="34" charset="-122"/>
                 <a:cs typeface="Arial" pitchFamily="34" charset="-120"/>
               </a:rPr>
+              <a:t>- Máximo 4 focos. Si hay más, se quedan los de mayor PRIORIDAD y se informa al usuario cuáles quedaron fuera. Si hay menos, elimina las filas sobrantes (nunca la fila 5).</a:t>
+            </a:r>
+            <a:endParaRPr lang="en-US" sz="600" dirty="0"/>
+          </a:p>
+          <a:p>
+            <a:pPr marL="0" indent="0">
+              <a:buNone/>
+            </a:pPr>
+            <a:r>
+              <a:rPr lang="en-US" sz="600" dirty="0">
+                <a:solidFill>
+                  <a:srgbClr val="222222"/>
+                </a:solidFill>
+                <a:latin typeface="Arial" pitchFamily="34" charset="0"/>
+                <a:ea typeface="Arial" pitchFamily="34" charset="-122"/>
+                <a:cs typeface="Arial" pitchFamily="34" charset="-120"/>
+              </a:rPr>
               <a:t> </a:t>
             </a:r>
             <a:endParaRPr lang="en-US" sz="600" dirty="0"/>
@@ -6883,7 +6900,7 @@
                 <a:ea typeface="Arial" pitchFamily="34" charset="-122"/>
                 <a:cs typeface="Arial" pitchFamily="34" charset="-120"/>
               </a:rPr>
-              <a:t>4. NIVEL Y PRIORIDAD POR TIPO DE EVENTO</a:t>
+              <a:t>4. NIVEL Y PRIORIDAD – SON DOS COSAS DISTINTAS</a:t>
             </a:r>
             <a:endParaRPr lang="en-US" sz="600" dirty="0"/>
           </a:p>
@@ -6900,7 +6917,7 @@
                 <a:ea typeface="Arial" pitchFamily="34" charset="-122"/>
                 <a:cs typeface="Arial" pitchFamily="34" charset="-120"/>
               </a:rPr>
-              <a:t>Tabla de prioridad (1 = mayor):</a:t>
+              <a:t>NIVEL = criticidad del foco. Lo define el TIPO del evento más grave del foco y determina el texto y el COLOR de la celda. No cambia por la reiteración ni por la posición del foco.</a:t>
             </a:r>
             <a:endParaRPr lang="en-US" sz="600" dirty="0"/>
           </a:p>
@@ -6917,7 +6934,7 @@
                 <a:ea typeface="Arial" pitchFamily="34" charset="-122"/>
                 <a:cs typeface="Arial" pitchFamily="34" charset="-120"/>
               </a:rPr>
-              <a:t>  1. ACC con lesión a personas ........ N1 · CRITICIDAD ALTA</a:t>
+              <a:t>  - N1 · CRITICIDAD ALTA (celda roja C62828): ACC con lesión a personas, ACC con daño material (DM), CAAP.</a:t>
             </a:r>
             <a:endParaRPr lang="en-US" sz="600" dirty="0"/>
           </a:p>
@@ -6934,7 +6951,7 @@
                 <a:ea typeface="Arial" pitchFamily="34" charset="-122"/>
                 <a:cs typeface="Arial" pitchFamily="34" charset="-120"/>
               </a:rPr>
-              <a:t>  2. ACC con daño material (DM) ....... N1 · CRITICIDAD ALTA</a:t>
+              <a:t>  - N2 · CRITICIDAD INTERMEDIA (celda naranja E67E22): CBP, HAP.</a:t>
             </a:r>
             <a:endParaRPr lang="en-US" sz="600" dirty="0"/>
           </a:p>
@@ -6951,7 +6968,7 @@
                 <a:ea typeface="Arial" pitchFamily="34" charset="-122"/>
                 <a:cs typeface="Arial" pitchFamily="34" charset="-120"/>
               </a:rPr>
-              <a:t>  3. CAAP ............................. N1 · CRITICIDAD ALTA</a:t>
+              <a:t>  - N3 (HBP): no genera foco; solo va en Recurrente.</a:t>
             </a:r>
             <a:endParaRPr lang="en-US" sz="600" dirty="0"/>
           </a:p>
@@ -6968,7 +6985,7 @@
                 <a:ea typeface="Arial" pitchFamily="34" charset="-122"/>
                 <a:cs typeface="Arial" pitchFamily="34" charset="-120"/>
               </a:rPr>
-              <a:t>  4. CBP (interacción próxima persona–situación) ... N2 · CRITICIDAD INTERMEDIA</a:t>
+              <a:t>  - Gravedad de los tipos de evento (para saber cuál es "el más grave" y para desempatar): ACC con lesión &gt; ACC con daño material &gt; CAAP &gt; CBP &gt; HAP.</a:t>
             </a:r>
             <a:endParaRPr lang="en-US" sz="600" dirty="0"/>
           </a:p>
@@ -6985,7 +7002,7 @@
                 <a:ea typeface="Arial" pitchFamily="34" charset="-122"/>
                 <a:cs typeface="Arial" pitchFamily="34" charset="-120"/>
               </a:rPr>
-              <a:t>  5. HAP (control crítico no implementado o erosionado) ... N2 · CRITICIDAD INTERMEDIA</a:t>
+              <a:t>PRIORIDAD = orden del foco en la tabla (foco 1 = primera fila). Es el número que va en la celda. Se asigna en este orden:</a:t>
             </a:r>
             <a:endParaRPr lang="en-US" sz="600" dirty="0"/>
           </a:p>
@@ -7002,7 +7019,7 @@
                 <a:ea typeface="Arial" pitchFamily="34" charset="-122"/>
                 <a:cs typeface="Arial" pitchFamily="34" charset="-120"/>
               </a:rPr>
-              <a:t>  —  HBP ............................. N3 · no ingresa como foco (solo Recurrente)</a:t>
+              <a:t>  - Prioridad 1°: focos reiterados que incluyen al menos un evento N1.</a:t>
             </a:r>
             <a:endParaRPr lang="en-US" sz="600" dirty="0"/>
           </a:p>
@@ -7019,7 +7036,7 @@
                 <a:ea typeface="Arial" pitchFamily="34" charset="-122"/>
                 <a:cs typeface="Arial" pitchFamily="34" charset="-120"/>
               </a:rPr>
-              <a:t>- Nivel del foco = nivel del evento de mayor prioridad entre sus eventos de origen (basta un ACC o CAAP para que el foco sea N1).</a:t>
+              <a:t>  - Prioridad 2°: focos reiterados solo con eventos N2.</a:t>
             </a:r>
             <a:endParaRPr lang="en-US" sz="600" dirty="0"/>
           </a:p>
@@ -7036,7 +7053,7 @@
                 <a:ea typeface="Arial" pitchFamily="34" charset="-122"/>
                 <a:cs typeface="Arial" pitchFamily="34" charset="-120"/>
               </a:rPr>
-              <a:t>- Orden de los focos: (1) focos por reiteración N1, (2) focos por reiteración N2, (3) focos por N1 aislado (ACC o CAAP sin reiteración), al final. Dentro de cada grupo: (a) el evento de mayor prioridad según la tabla, (b) mayor cantidad de eventos, (c) evento más reciente.</a:t>
+              <a:t>  - Prioridad 3°: focos aislados N1 (un solo ACC o CAAP).</a:t>
             </a:r>
             <a:endParaRPr lang="en-US" sz="600" dirty="0"/>
           </a:p>
@@ -7053,7 +7070,7 @@
                 <a:ea typeface="Arial" pitchFamily="34" charset="-122"/>
                 <a:cs typeface="Arial" pitchFamily="34" charset="-120"/>
               </a:rPr>
-              <a:t>- Un foco por N1 aislado mantiene el nivel N1 (celda roja), aunque vaya al final del orden.</a:t>
+              <a:t>  - Prioridad 4°: focos aislados N2 (un solo CBP o HAP).</a:t>
             </a:r>
             <a:endParaRPr lang="en-US" sz="600" dirty="0"/>
           </a:p>
@@ -7070,7 +7087,7 @@
                 <a:ea typeface="Arial" pitchFamily="34" charset="-122"/>
                 <a:cs typeface="Arial" pitchFamily="34" charset="-120"/>
               </a:rPr>
-              <a:t>- Texto de la celda: número del foco + "N1 · CRITICIDAD ALTA" o "N2 · CRITICIDAD INTERMEDIA". Color: N1 = rojo C62828; N2 = naranja E67E22. Ajusta texto y color de cada fila al nivel real (la plantilla trae 3 filas N1 y 1 N2 solo como referencia).</a:t>
+              <a:t>  - Desempate dentro del mismo grupo: (a) tipo de evento más grave según la gravedad de arriba, (b) mayor cantidad de eventos, (c) evento más reciente.</a:t>
             </a:r>
             <a:endParaRPr lang="en-US" sz="600" dirty="0"/>
           </a:p>
@@ -7087,6 +7104,40 @@
                 <a:ea typeface="Arial" pitchFamily="34" charset="-122"/>
                 <a:cs typeface="Arial" pitchFamily="34" charset="-120"/>
               </a:rPr>
+              <a:t>Ejemplos: un foco reiterado con 2 HAP es N2 (naranja) y va ANTES que un CAAP aislado, que es N1 (rojo). Un CAAP aislado sigue siendo N1 (rojo) aunque quede en las últimas filas.</a:t>
+            </a:r>
+            <a:endParaRPr lang="en-US" sz="600" dirty="0"/>
+          </a:p>
+          <a:p>
+            <a:pPr marL="0" indent="0">
+              <a:buNone/>
+            </a:pPr>
+            <a:r>
+              <a:rPr lang="en-US" sz="600" dirty="0">
+                <a:solidFill>
+                  <a:srgbClr val="222222"/>
+                </a:solidFill>
+                <a:latin typeface="Arial" pitchFamily="34" charset="0"/>
+                <a:ea typeface="Arial" pitchFamily="34" charset="-122"/>
+                <a:cs typeface="Arial" pitchFamily="34" charset="-120"/>
+              </a:rPr>
+              <a:t>- Texto de la celda: número de prioridad + "N1 · CRITICIDAD ALTA" o "N2 · CRITICIDAD INTERMEDIA". Ajusta texto y color de cada fila al nivel real (la plantilla trae 3 filas N1 y 1 N2 solo como referencia).</a:t>
+            </a:r>
+            <a:endParaRPr lang="en-US" sz="600" dirty="0"/>
+          </a:p>
+          <a:p>
+            <a:pPr marL="0" indent="0">
+              <a:buNone/>
+            </a:pPr>
+            <a:r>
+              <a:rPr lang="en-US" sz="600" dirty="0">
+                <a:solidFill>
+                  <a:srgbClr val="222222"/>
+                </a:solidFill>
+                <a:latin typeface="Arial" pitchFamily="34" charset="0"/>
+                <a:ea typeface="Arial" pitchFamily="34" charset="-122"/>
+                <a:cs typeface="Arial" pitchFamily="34" charset="-120"/>
+              </a:rPr>
               <a:t> </a:t>
             </a:r>
             <a:endParaRPr lang="en-US" sz="600" dirty="0"/>
@@ -7308,7 +7359,7 @@
                 <a:ea typeface="Arial" pitchFamily="34" charset="-122"/>
                 <a:cs typeface="Arial" pitchFamily="34" charset="-120"/>
               </a:rPr>
-              <a:t>- Lista TODOS los eventos N1/N2 del período que originan el foco (mínimo 2 en focos por reiteración; 1 en focos por N1 aislado, agregando al final "(evento aislado)"), ordenados según la tabla de prioridad del punto 4. Si son más de 4, lista los 4 de mayor prioridad y agrega "+ N eventos más".</a:t>
+              <a:t>- Lista TODOS los eventos N1/N2 del período que originan el foco (mínimo 2 en focos reiterados; 1 en focos aislados, agregando al final "(evento aislado)"), ordenados por gravedad del tipo de evento (punto 4). Si son más de 4, lista los 4 más graves y agrega "+ N eventos más".</a:t>
             </a:r>
             <a:endParaRPr lang="en-US" sz="600" dirty="0"/>
           </a:p>
@@ -7971,7 +8022,7 @@
                 <a:ea typeface="Arial" pitchFamily="34" charset="-122"/>
                 <a:cs typeface="Arial" pitchFamily="34" charset="-120"/>
               </a:rPr>
-              <a:t>- eventos N1/N2 usados en cada foco y los que quedaron fuera (p. ej., CBP o HAP aislados sin reiteración), con el motivo;</a:t>
+              <a:t>- eventos N1/N2 usados en cada foco y los que quedaron fuera (p. ej., focos aislados que no cupieron en las 4 filas), con el motivo;</a:t>
             </a:r>
             <a:endParaRPr lang="en-US" sz="600" dirty="0"/>
           </a:p>
@@ -8005,7 +8056,7 @@
                 <a:ea typeface="Arial" pitchFamily="34" charset="-122"/>
                 <a:cs typeface="Arial" pitchFamily="34" charset="-120"/>
               </a:rPr>
-              <a:t>Antes de entregar, confirma que: cada ID existe en el Excel; cada foco tiene al menos 2 eventos N1/N2 relacionados, salvo los focos por N1 aislado, que van al final; el nivel y el orden de los focos siguen la tabla de prioridad; ningún HBP aparece como foco o evento de origen; los conteos de indicadores y Recurrente cuadran; y no quedan textos guía.</a:t>
+              <a:t>Antes de entregar, confirma que: cada ID existe en el Excel; los focos reiterados tienen al menos 2 eventos N1/N2 relacionados y van antes que los aislados; el NIVEL (color) de cada foco corresponde a su evento más grave y la PRIORIDAD (orden) sigue el punto 4; ningún HBP aparece como foco o evento de origen; los conteos de indicadores y Recurrente cuadran; y no quedan textos guía.</a:t>
             </a:r>
             <a:endParaRPr lang="en-US" sz="600" dirty="0"/>
           </a:p>
@@ -8667,7 +8718,7 @@
                 <a:ea typeface="Arial" pitchFamily="34" charset="-122"/>
                 <a:cs typeface="Arial" pitchFamily="34" charset="-120"/>
               </a:rPr>
-              <a:t>SELECCIÓN DE FOCOS · REITERACIÓN</a:t>
+              <a:t>SELECCIÓN Y PRIORIDAD DE FOCOS</a:t>
             </a:r>
             <a:endParaRPr lang="en-US" sz="1050" dirty="0"/>
           </a:p>
@@ -8706,7 +8757,7 @@
                 <a:ea typeface="Arial" pitchFamily="34" charset="-122"/>
                 <a:cs typeface="Arial" pitchFamily="34" charset="-120"/>
               </a:rPr>
-              <a:t>Un foco se crea solo si 2 o más eventos N1/N2 (ACC, CAAP, HAP, CBP) de los últimos 14 días se repiten en un mismo tema (ej.: izaje). Un ACC o CAAP aislado también es foco, pero al final. CBP/HAP aislados no. Máx. 4 focos; HBP no cuentan.</a:t>
+              <a:t>Prioridad = orden del foco en la tabla: 1° reiterados con N1 · 2° reiterados solo N2 · 3° aislados N1 · 4° aislados N2. Reiterado = 2 o más eventos N1/N2 del mismo tema. Empate: tipo más grave, más eventos, más reciente. Máx. 4; HBP no cuentan.</a:t>
             </a:r>
             <a:endParaRPr lang="en-US" sz="930" dirty="0"/>
           </a:p>
@@ -8850,7 +8901,7 @@
                 <a:ea typeface="Arial" pitchFamily="34" charset="-122"/>
                 <a:cs typeface="Arial" pitchFamily="34" charset="-120"/>
               </a:rPr>
-              <a:t>NIVEL Y PRIORIDAD</a:t>
+              <a:t>NIVEL (CRITICIDAD)</a:t>
             </a:r>
             <a:endParaRPr lang="en-US" sz="1050" dirty="0"/>
           </a:p>
@@ -8889,7 +8940,7 @@
                 <a:ea typeface="Arial" pitchFamily="34" charset="-122"/>
                 <a:cs typeface="Arial" pitchFamily="34" charset="-120"/>
               </a:rPr>
-              <a:t>Prioridad por tipo: 1 ACC con lesión · 2 ACC daño material · 3 CAAP (N1, roja) · 4 CBP · 5 HAP (N2, naranja). Nivel = su evento de mayor prioridad. Orden: reiterados N1 → reiterados N2 → N1 aislados; empate: más eventos, más reciente.</a:t>
+              <a:t>Lo define el evento más grave del foco y fija el color: N1 · alta (roja) = ACC con lesión, ACC daño material, CAAP. N2 · intermedia (naranja) = CBP, HAP. No cambia por la reiteración ni por el orden. En la celda: N° de prioridad + nivel.</a:t>
             </a:r>
             <a:endParaRPr lang="en-US" sz="930" dirty="0"/>
           </a:p>
@@ -9255,7 +9306,7 @@
                 <a:ea typeface="Arial" pitchFamily="34" charset="-122"/>
                 <a:cs typeface="Arial" pitchFamily="34" charset="-120"/>
               </a:rPr>
-              <a:t>Todos los eventos N1/N2 del tema que originan el foco (mín. 2; N1 aislado: 1, con "(evento aislado)"), ordenados por prioridad. Formato: [Turno] TIPO ID – EECC: qué ocurrió.</a:t>
+              <a:t>Todos los eventos N1/N2 del tema que originan el foco, del más grave al menos grave. Foco aislado: 1 evento + "(evento aislado)". Formato: [Turno] TIPO ID – EECC: qué ocurrió.</a:t>
             </a:r>
             <a:endParaRPr lang="en-US" sz="930" dirty="0"/>
           </a:p>
@@ -10695,7 +10746,7 @@
               <a:buChar char="•"/>
             </a:pPr>
             <a:r>
-              <a:rPr lang="en-US" sz="760" dirty="0" b="1">
+              <a:rPr lang="en-US" sz="740" dirty="0" b="1">
                 <a:solidFill>
                   <a:srgbClr val="C62828"/>
                 </a:solidFill>
@@ -10706,15 +10757,15 @@
               <a:t>N1 · Criticidad alta: </a:t>
             </a:r>
             <a:r>
-              <a:rPr lang="en-US" sz="760" dirty="0" b="0">
-                <a:solidFill>
-                  <a:srgbClr val="222222"/>
-                </a:solidFill>
-                <a:latin typeface="Arial" pitchFamily="34" charset="0"/>
-                <a:ea typeface="Arial" pitchFamily="34" charset="-122"/>
-                <a:cs typeface="Arial" pitchFamily="34" charset="-120"/>
-              </a:rPr>
-              <a:t>consecuencias graves o fatales; gestión prioritaria. Prioridad: 1 ACC con lesión · 2 ACC daño material · 3 CAAP.</a:t>
+              <a:rPr lang="en-US" sz="740" dirty="0" b="0">
+                <a:solidFill>
+                  <a:srgbClr val="222222"/>
+                </a:solidFill>
+                <a:latin typeface="Arial" pitchFamily="34" charset="0"/>
+                <a:ea typeface="Arial" pitchFamily="34" charset="-122"/>
+                <a:cs typeface="Arial" pitchFamily="34" charset="-120"/>
+              </a:rPr>
+              <a:t>consecuencias graves o fatales; gestión prioritaria. ACC con lesión, ACC con daño material y CAAP.</a:t>
             </a:r>
             <a:endParaRPr lang="en-US" sz="930" dirty="0"/>
           </a:p>
@@ -10727,7 +10778,7 @@
               <a:buChar char="•"/>
             </a:pPr>
             <a:r>
-              <a:rPr lang="en-US" sz="760" dirty="0" b="1">
+              <a:rPr lang="en-US" sz="740" dirty="0" b="1">
                 <a:solidFill>
                   <a:srgbClr val="B35C00"/>
                 </a:solidFill>
@@ -10738,15 +10789,15 @@
               <a:t>N2 · Criticidad intermedia: </a:t>
             </a:r>
             <a:r>
-              <a:rPr lang="en-US" sz="760" dirty="0" b="0">
-                <a:solidFill>
-                  <a:srgbClr val="222222"/>
-                </a:solidFill>
-                <a:latin typeface="Arial" pitchFamily="34" charset="0"/>
-                <a:ea typeface="Arial" pitchFamily="34" charset="-122"/>
-                <a:cs typeface="Arial" pitchFamily="34" charset="-120"/>
-              </a:rPr>
-              <a:t>gestión y seguimiento. Prioridad: 4 CBP (interacción próxima persona–situación) · 5 HAP (control crítico no implementado o erosionado).</a:t>
+              <a:rPr lang="en-US" sz="740" dirty="0" b="0">
+                <a:solidFill>
+                  <a:srgbClr val="222222"/>
+                </a:solidFill>
+                <a:latin typeface="Arial" pitchFamily="34" charset="0"/>
+                <a:ea typeface="Arial" pitchFamily="34" charset="-122"/>
+                <a:cs typeface="Arial" pitchFamily="34" charset="-120"/>
+              </a:rPr>
+              <a:t>gestión y seguimiento. CBP (interacción próxima persona–situación) y HAP (control crítico no implementado o erosionado).</a:t>
             </a:r>
             <a:endParaRPr lang="en-US" sz="930" dirty="0"/>
           </a:p>
@@ -10759,7 +10810,7 @@
               <a:buChar char="•"/>
             </a:pPr>
             <a:r>
-              <a:rPr lang="en-US" sz="760" dirty="0" b="1">
+              <a:rPr lang="en-US" sz="740" dirty="0" b="1">
                 <a:solidFill>
                   <a:srgbClr val="222222"/>
                 </a:solidFill>
@@ -10770,7 +10821,7 @@
               <a:t>N3 · HBP: </a:t>
             </a:r>
             <a:r>
-              <a:rPr lang="en-US" sz="760" dirty="0" b="0">
+              <a:rPr lang="en-US" sz="740" dirty="0" b="0">
                 <a:solidFill>
                   <a:srgbClr val="222222"/>
                 </a:solidFill>
@@ -10791,7 +10842,7 @@
               <a:buChar char="•"/>
             </a:pPr>
             <a:r>
-              <a:rPr lang="en-US" sz="760" dirty="0" b="1">
+              <a:rPr lang="en-US" sz="740" dirty="0" b="1">
                 <a:solidFill>
                   <a:srgbClr val="1F3D6B"/>
                 </a:solidFill>
@@ -10799,18 +10850,18 @@
                 <a:ea typeface="Arial" pitchFamily="34" charset="-122"/>
                 <a:cs typeface="Arial" pitchFamily="34" charset="-120"/>
               </a:rPr>
-              <a:t>Foco = reiteración: </a:t>
-            </a:r>
-            <a:r>
-              <a:rPr lang="en-US" sz="760" dirty="0" b="0">
-                <a:solidFill>
-                  <a:srgbClr val="222222"/>
-                </a:solidFill>
-                <a:latin typeface="Arial" pitchFamily="34" charset="0"/>
-                <a:ea typeface="Arial" pitchFamily="34" charset="-122"/>
-                <a:cs typeface="Arial" pitchFamily="34" charset="-120"/>
-              </a:rPr>
-              <a:t>2 o más eventos N1/N2 del mismo tema en 14 días. ACC o CAAP aislado: foco de menor prioridad.</a:t>
+              <a:t>Nivel ≠ prioridad: </a:t>
+            </a:r>
+            <a:r>
+              <a:rPr lang="en-US" sz="740" dirty="0" b="0">
+                <a:solidFill>
+                  <a:srgbClr val="222222"/>
+                </a:solidFill>
+                <a:latin typeface="Arial" pitchFamily="34" charset="0"/>
+                <a:ea typeface="Arial" pitchFamily="34" charset="-122"/>
+                <a:cs typeface="Arial" pitchFamily="34" charset="-120"/>
+              </a:rPr>
+              <a:t>el nivel es la criticidad (color); la prioridad es el orden del foco: 1° reiterados con N1 · 2° reiterados N2 · 3° aislados N1 · 4° aislados N2.</a:t>
             </a:r>
             <a:endParaRPr lang="en-US" sz="930" dirty="0"/>
           </a:p>

</xml_diff>

<commit_message>
Formato Assurance ITO v1.1: N1 aislados antes que N2 reiterados
Prioridad: N1 reiterados, N1 aislados, N2 reiterados, N2 aislados.

Co-Authored-By: Claude Opus 5.5 <noreply@anthropic.com>
Claude-Session: https://claude.ai/code/session_017MaLNPnWzNhW9Tdfmjv67V
</commit_message>
<xml_diff>
--- a/FORMATO_ASSURANCE_ITO_v1.1.pptx
+++ b/FORMATO_ASSURANCE_ITO_v1.1.pptx
@@ -6849,7 +6849,7 @@
                 <a:ea typeface="Arial" pitchFamily="34" charset="-122"/>
                 <a:cs typeface="Arial" pitchFamily="34" charset="-120"/>
               </a:rPr>
-              <a:t>- Foco AISLADO: tema con un solo evento N1/N2 en el período. Los focos aislados SÍ se incluyen (sean ACC, CAAP, CBP o HAP), pero siempre después de todos los focos reiterados (ver punto 4).</a:t>
+              <a:t>- Foco AISLADO: tema con un solo evento N1/N2 en el período. Los focos aislados SÍ se incluyen (sean ACC, CAAP, CBP o HAP); su prioridad depende de su nivel (ver punto 4).</a:t>
             </a:r>
             <a:endParaRPr lang="en-US" sz="600" dirty="0"/>
           </a:p>
@@ -7019,7 +7019,7 @@
                 <a:ea typeface="Arial" pitchFamily="34" charset="-122"/>
                 <a:cs typeface="Arial" pitchFamily="34" charset="-120"/>
               </a:rPr>
-              <a:t>  - Prioridad 1°: focos reiterados que incluyen al menos un evento N1.</a:t>
+              <a:t>  - Prioridad 1°: focos N1 reiterados (2 o más eventos del tema, al menos uno N1).</a:t>
             </a:r>
             <a:endParaRPr lang="en-US" sz="600" dirty="0"/>
           </a:p>
@@ -7036,7 +7036,7 @@
                 <a:ea typeface="Arial" pitchFamily="34" charset="-122"/>
                 <a:cs typeface="Arial" pitchFamily="34" charset="-120"/>
               </a:rPr>
-              <a:t>  - Prioridad 2°: focos reiterados solo con eventos N2.</a:t>
+              <a:t>  - Prioridad 2°: focos N1 aislados (un solo ACC o CAAP).</a:t>
             </a:r>
             <a:endParaRPr lang="en-US" sz="600" dirty="0"/>
           </a:p>
@@ -7053,7 +7053,7 @@
                 <a:ea typeface="Arial" pitchFamily="34" charset="-122"/>
                 <a:cs typeface="Arial" pitchFamily="34" charset="-120"/>
               </a:rPr>
-              <a:t>  - Prioridad 3°: focos aislados N1 (un solo ACC o CAAP).</a:t>
+              <a:t>  - Prioridad 3°: focos N2 reiterados (2 o más eventos del tema, todos CBP o HAP).</a:t>
             </a:r>
             <a:endParaRPr lang="en-US" sz="600" dirty="0"/>
           </a:p>
@@ -7070,7 +7070,7 @@
                 <a:ea typeface="Arial" pitchFamily="34" charset="-122"/>
                 <a:cs typeface="Arial" pitchFamily="34" charset="-120"/>
               </a:rPr>
-              <a:t>  - Prioridad 4°: focos aislados N2 (un solo CBP o HAP).</a:t>
+              <a:t>  - Prioridad 4°: focos N2 aislados (un solo CBP o HAP).</a:t>
             </a:r>
             <a:endParaRPr lang="en-US" sz="600" dirty="0"/>
           </a:p>
@@ -7087,6 +7087,23 @@
                 <a:ea typeface="Arial" pitchFamily="34" charset="-122"/>
                 <a:cs typeface="Arial" pitchFamily="34" charset="-120"/>
               </a:rPr>
+              <a:t>  - Regla general: primero el nivel (todo N1 antes que todo N2) y, dentro de cada nivel, reiterado antes que aislado.</a:t>
+            </a:r>
+            <a:endParaRPr lang="en-US" sz="600" dirty="0"/>
+          </a:p>
+          <a:p>
+            <a:pPr marL="0" indent="0">
+              <a:buNone/>
+            </a:pPr>
+            <a:r>
+              <a:rPr lang="en-US" sz="600" dirty="0">
+                <a:solidFill>
+                  <a:srgbClr val="222222"/>
+                </a:solidFill>
+                <a:latin typeface="Arial" pitchFamily="34" charset="0"/>
+                <a:ea typeface="Arial" pitchFamily="34" charset="-122"/>
+                <a:cs typeface="Arial" pitchFamily="34" charset="-120"/>
+              </a:rPr>
               <a:t>  - Desempate dentro del mismo grupo: (a) tipo de evento más grave según la gravedad de arriba, (b) mayor cantidad de eventos, (c) evento más reciente.</a:t>
             </a:r>
             <a:endParaRPr lang="en-US" sz="600" dirty="0"/>
@@ -7104,7 +7121,7 @@
                 <a:ea typeface="Arial" pitchFamily="34" charset="-122"/>
                 <a:cs typeface="Arial" pitchFamily="34" charset="-120"/>
               </a:rPr>
-              <a:t>Ejemplos: un foco reiterado con 2 HAP es N2 (naranja) y va ANTES que un CAAP aislado, que es N1 (rojo). Un CAAP aislado sigue siendo N1 (rojo) aunque quede en las últimas filas.</a:t>
+              <a:t>Ejemplos: un CAAP aislado (N1, rojo) va ANTES que un foco reiterado con 2 HAP (N2, naranja). Un foco reiterado con 1 CAAP y 3 HAP es N1 y va antes que un CAAP aislado.</a:t>
             </a:r>
             <a:endParaRPr lang="en-US" sz="600" dirty="0"/>
           </a:p>
@@ -8056,7 +8073,7 @@
                 <a:ea typeface="Arial" pitchFamily="34" charset="-122"/>
                 <a:cs typeface="Arial" pitchFamily="34" charset="-120"/>
               </a:rPr>
-              <a:t>Antes de entregar, confirma que: cada ID existe en el Excel; los focos reiterados tienen al menos 2 eventos N1/N2 relacionados y van antes que los aislados; el NIVEL (color) de cada foco corresponde a su evento más grave y la PRIORIDAD (orden) sigue el punto 4; ningún HBP aparece como foco o evento de origen; los conteos de indicadores y Recurrente cuadran; y no quedan textos guía.</a:t>
+              <a:t>Antes de entregar, confirma que: cada ID existe en el Excel; los focos reiterados tienen al menos 2 eventos N1/N2 relacionados; todos los focos N1 van antes que los N2 y, dentro de cada nivel, los reiterados antes que los aislados; el NIVEL (color) de cada foco corresponde a su evento más grave y la PRIORIDAD (orden) sigue el punto 4; ningún HBP aparece como foco o evento de origen; los conteos de indicadores y Recurrente cuadran; y no quedan textos guía.</a:t>
             </a:r>
             <a:endParaRPr lang="en-US" sz="600" dirty="0"/>
           </a:p>
@@ -8757,7 +8774,7 @@
                 <a:ea typeface="Arial" pitchFamily="34" charset="-122"/>
                 <a:cs typeface="Arial" pitchFamily="34" charset="-120"/>
               </a:rPr>
-              <a:t>Prioridad = orden del foco en la tabla: 1° reiterados con N1 · 2° reiterados solo N2 · 3° aislados N1 · 4° aislados N2. Reiterado = 2 o más eventos N1/N2 del mismo tema. Empate: tipo más grave, más eventos, más reciente. Máx. 4; HBP no cuentan.</a:t>
+              <a:t>Prioridad = orden del foco en la tabla: 1° N1 reiterados · 2° N1 aislados · 3° N2 reiterados · 4° N2 aislados. Reiterado = 2 o más eventos N1/N2 del mismo tema. Empate: tipo más grave, más eventos, más reciente. Máx. 4; HBP no cuentan.</a:t>
             </a:r>
             <a:endParaRPr lang="en-US" sz="930" dirty="0"/>
           </a:p>
@@ -10861,7 +10878,7 @@
                 <a:ea typeface="Arial" pitchFamily="34" charset="-122"/>
                 <a:cs typeface="Arial" pitchFamily="34" charset="-120"/>
               </a:rPr>
-              <a:t>el nivel es la criticidad (color); la prioridad es el orden del foco: 1° reiterados con N1 · 2° reiterados N2 · 3° aislados N1 · 4° aislados N2.</a:t>
+              <a:t>el nivel es la criticidad (color); la prioridad es el orden del foco: 1° N1 reiterados · 2° N1 aislados · 3° N2 reiterados · 4° N2 aislados.</a:t>
             </a:r>
             <a:endParaRPr lang="en-US" sz="930" dirty="0"/>
           </a:p>

</xml_diff>

<commit_message>
Assurance ITO: precisar turnos en instrucciones IA y agregar prompt de uso
- Turno entrante vs. turno de los datos; FECHA/PERÍODO = vigencia.
- PROMPT_ASSURANCE_IA.txt para que la IA lea las instrucciones ocultas.

Co-Authored-By: Claude Opus 5.5 <noreply@anthropic.com>
Claude-Session: https://claude.ai/code/session_017MaLNPnWzNhW9Tdfmjv67V
</commit_message>
<xml_diff>
--- a/FORMATO_ASSURANCE_ITO_v1.1.pptx
+++ b/FORMATO_ASSURANCE_ITO_v1.1.pptx
@@ -6594,7 +6594,7 @@
                 <a:ea typeface="Arial" pitchFamily="34" charset="-122"/>
                 <a:cs typeface="Arial" pitchFamily="34" charset="-120"/>
               </a:rPr>
-              <a:t>- El Excel no trae el turno: el turno y la fecha de cierre los indica el usuario. Si no están claros, pregunta antes de completar.</a:t>
+              <a:t>- El Excel no trae el turno. El usuario debe indicar: (a) el turno ENTRANTE para el que se prepara el Assurance, (b) su período de vigencia, (c) la fecha de cierre de los datos y (d) el turno que trabajó en el período de los datos (normalmente el turno saliente). Si falta alguno, pregunta antes de completar.</a:t>
             </a:r>
             <a:endParaRPr lang="en-US" sz="600" dirty="0"/>
           </a:p>
@@ -7393,6 +7393,23 @@
                 <a:ea typeface="Arial" pitchFamily="34" charset="-122"/>
                 <a:cs typeface="Arial" pitchFamily="34" charset="-120"/>
               </a:rPr>
+              <a:t>- La marca de turno ([T1-3] o [T2-4]) es la del turno que trabajó en el período de los datos, indicado por el usuario.</a:t>
+            </a:r>
+            <a:endParaRPr lang="en-US" sz="600" dirty="0"/>
+          </a:p>
+          <a:p>
+            <a:pPr marL="0" indent="0">
+              <a:buNone/>
+            </a:pPr>
+            <a:r>
+              <a:rPr lang="en-US" sz="600" dirty="0">
+                <a:solidFill>
+                  <a:srgbClr val="222222"/>
+                </a:solidFill>
+                <a:latin typeface="Arial" pitchFamily="34" charset="0"/>
+                <a:ea typeface="Arial" pitchFamily="34" charset="-122"/>
+                <a:cs typeface="Arial" pitchFamily="34" charset="-120"/>
+              </a:rPr>
               <a:t>- Formato fijo por evento: "[T1-3] TIPO ID – EECC:" (en negrita) + qué ocurrió, en una frase de hasta 120 caracteres. TIPO = ACC, CAAP, HAP o CBP.</a:t>
             </a:r>
             <a:endParaRPr lang="en-US" sz="600" dirty="0"/>
@@ -7750,7 +7767,7 @@
                 <a:ea typeface="Arial" pitchFamily="34" charset="-122"/>
                 <a:cs typeface="Arial" pitchFamily="34" charset="-120"/>
               </a:rPr>
-              <a:t>- Título: "ASSURANCE TURNO 1-3" o "ASSURANCE TURNO 2-4". Fecha/Período: "DD al DD MES". Turno: marca ☒ en el que corresponde.</a:t>
+              <a:t>- Título: "ASSURANCE TURNO 1-3" o "ASSURANCE TURNO 2-4", según el turno ENTRANTE. FECHA / PERÍODO: vigencia del turno entrante, "DD al DD MES" (el período de los datos va en la franja de indicadores, no aquí). TURNO: marca ☒ en el turno entrante.</a:t>
             </a:r>
             <a:endParaRPr lang="en-US" sz="600" dirty="0"/>
           </a:p>

</xml_diff>